<commit_message>
presentations: accessibility pass, captions, presenter name (wip)
</commit_message>
<xml_diff>
--- a/presentations/b02-identity/B02_Identity.pptx
+++ b/presentations/b02-identity/B02_Identity.pptx
@@ -119,14 +119,14 @@
   <p:extLst>
     <p:ext uri="{521415D9-36F7-43E2-AB2F-B90AF26B5E84}">
       <p14:sectionLst xmlns:p14="http://schemas.microsoft.com/office/powerpoint/2010/main">
-        <p14:section name="Why identity matters" id="{36b658b9-63e0-0b5b-0be2-a89fc06b46f9}">
+        <p14:section name="Why identity matters" id="{252d397d-f72b-6d7a-7c8d-65f278d89d7e}">
           <p14:sldIdLst>
             <p14:sldId id="256"/>
             <p14:sldId id="257"/>
             <p14:sldId id="258"/>
           </p14:sldIdLst>
         </p14:section>
-        <p14:section name="What changes" id="{ab1d69bd-30c9-c07e-f211-fd3127e8a71d}">
+        <p14:section name="What changes" id="{55052109-6183-7980-b9ce-aa6e0993bc8c}">
           <p14:sldIdLst>
             <p14:sldId id="259"/>
             <p14:sldId id="260"/>
@@ -134,19 +134,19 @@
             <p14:sldId id="262"/>
           </p14:sldIdLst>
         </p14:section>
-        <p14:section name="Who owns it" id="{88d589cd-7428-5ac1-c542-92fc8e6e5e4f}">
+        <p14:section name="Who owns it" id="{f2a4c398-c262-7b73-f8d9-8ba02308393d}">
           <p14:sldIdLst>
             <p14:sldId id="263"/>
           </p14:sldIdLst>
         </p14:section>
-        <p14:section name="How to do it" id="{f2df7bcd-7e6e-2685-7605-eb5db27c59d9}">
+        <p14:section name="How to do it" id="{fb486a26-0329-f58a-ba66-8cba11cfd0e4}">
           <p14:sldIdLst>
             <p14:sldId id="264"/>
             <p14:sldId id="265"/>
             <p14:sldId id="266"/>
           </p14:sldIdLst>
         </p14:section>
-        <p14:section name="Backup" id="{e0a784e4-1f72-8198-80d8-b40e0aa8fedc}">
+        <p14:section name="Backup" id="{47bd790a-5004-4587-2bc3-d31c63dfd5aa}">
           <p14:sldIdLst>
             <p14:sldId id="267"/>
             <p14:sldId id="268"/>
@@ -556,7 +556,7 @@
           <a:p>
             <a:r>
               <a:rPr lang="en-US" dirty="0"/>
-              <a:t>[0:00–0:29]  This briefing comes from Book 02 of the Modernization Workbook, Identity and Directory: the move from Active Directory to Entra ID.
+              <a:t>[0:00–0:29]  This briefing comes from Book 02 of the Federal Modernization Workbook, Identity and Directory: the move from Active Directory to Entra ID.
 I'll take it through four questions. Why identity matters now. What actually changes when a directory moves to the cloud. Who has to own which decisions. And how to do it without losing the governance that twenty-five years of Active Directory quietly carried.
 The short version: this is not a directory upgrade. It decides whether every security control after it works.
 Workbook: Book 02, index.</a:t>
@@ -1954,7 +1954,7 @@
                   <a:schemeClr val="accent5"/>
                 </a:solidFill>
               </a:rPr>
-              <a:t>Modernization Workbook  ·  Book 02 Identity &amp; Directory</a:t>
+              <a:t>Federal Modernization Workbook  ·  Book 02 Identity &amp; Directory</a:t>
             </a:r>
             <a:endParaRPr lang="en-US" sz="1000" dirty="0"/>
           </a:p>
@@ -2435,7 +2435,90 @@
       </p:sp>
       <p:sp>
         <p:nvSpPr>
-          <p:cNvPr id="4" name="Agenda line"/>
+          <p:cNvPr id="4" name="Presenter"/>
+          <p:cNvSpPr txBox="1"/>
+          <p:nvPr/>
+        </p:nvSpPr>
+        <p:spPr>
+          <a:xfrm>
+            <a:off x="731520" y="5897880"/>
+            <a:ext cx="6858000" cy="365760"/>
+          </a:xfrm>
+          <a:prstGeom prst="rect">
+            <a:avLst/>
+          </a:prstGeom>
+          <a:noFill/>
+          <a:ln/>
+        </p:spPr>
+        <p:txBody>
+          <a:bodyPr wrap="square" lIns="0" tIns="0" rIns="0" bIns="0" rtlCol="0" anchor="ctr"/>
+          <a:lstStyle/>
+          <a:p>
+            <a:pPr indent="0" marL="0">
+              <a:buNone/>
+            </a:pPr>
+            <a:r>
+              <a:rPr lang="en-US" sz="1600" dirty="0">
+                <a:solidFill>
+                  <a:srgbClr val="64748B"/>
+                </a:solidFill>
+              </a:rPr>
+              <a:t>Presented by  </a:t>
+            </a:r>
+            <a:pPr indent="0" marL="0">
+              <a:buNone/>
+            </a:pPr>
+            <a:r>
+              <a:rPr lang="en-US" sz="1600" b="1" dirty="0">
+                <a:solidFill>
+                  <a:srgbClr val="1F2A44"/>
+                </a:solidFill>
+              </a:rPr>
+              <a:t>Michael F. Stratton</a:t>
+            </a:r>
+            <a:endParaRPr lang="en-US" sz="1600" dirty="0"/>
+          </a:p>
+        </p:txBody>
+      </p:sp>
+      <p:sp>
+        <p:nvSpPr>
+          <p:cNvPr id="5" name="Disclaimer"/>
+          <p:cNvSpPr txBox="1"/>
+          <p:nvPr/>
+        </p:nvSpPr>
+        <p:spPr>
+          <a:xfrm>
+            <a:off x="731520" y="6309360"/>
+            <a:ext cx="8686800" cy="274320"/>
+          </a:xfrm>
+          <a:prstGeom prst="rect">
+            <a:avLst/>
+          </a:prstGeom>
+          <a:noFill/>
+          <a:ln/>
+        </p:spPr>
+        <p:txBody>
+          <a:bodyPr wrap="square" lIns="0" tIns="0" rIns="0" bIns="0" rtlCol="0" anchor="ctr"/>
+          <a:lstStyle/>
+          <a:p>
+            <a:pPr indent="0" marL="0">
+              <a:buNone/>
+            </a:pPr>
+            <a:r>
+              <a:rPr lang="en-US" sz="1050" dirty="0">
+                <a:solidFill>
+                  <a:srgbClr val="64748B"/>
+                </a:solidFill>
+              </a:rPr>
+              <a:t>Not an official U.S. government publication. Independent technical analysis; not reviewed or endorsed by any federal agency.</a:t>
+            </a:r>
+            <a:endParaRPr lang="en-US" sz="1050" dirty="0"/>
+          </a:p>
+        </p:txBody>
+      </p:sp>
+      <p:sp>
+        <p:nvSpPr>
+          <p:cNvPr id="6" name="Agenda line"/>
           <p:cNvSpPr txBox="1"/>
           <p:nvPr/>
         </p:nvSpPr>
@@ -2537,7 +2620,7 @@
       </p:sp>
       <p:sp>
         <p:nvSpPr>
-          <p:cNvPr id="5" name="Series line"/>
+          <p:cNvPr id="7" name="Series line"/>
           <p:cNvSpPr txBox="1"/>
           <p:nvPr/>
         </p:nvSpPr>
@@ -2565,7 +2648,7 @@
                   <a:srgbClr val="1F2A44"/>
                 </a:solidFill>
               </a:rPr>
-              <a:t>Modernization Workbook</a:t>
+              <a:t>Federal Modernization Workbook</a:t>
             </a:r>
             <a:endParaRPr lang="en-US" sz="1600" dirty="0"/>
           </a:p>
@@ -2653,7 +2736,13 @@
       </p:sp>
       <p:sp>
         <p:nvSpPr>
-          <p:cNvPr id="3" name="Tag How"/>
+          <p:cNvPr id="3" name="Tag How" descr="">
+            <a:extLst>
+              <a:ext uri="{C183D7F6-B498-43B3-948B-1728B52AA6E4}">
+                <adec:decorative xmlns:adec="http://schemas.microsoft.com/office/drawing/2017/decorative" val="1"/>
+              </a:ext>
+            </a:extLst>
+          </p:cNvPr>
           <p:cNvSpPr/>
           <p:nvPr/>
         </p:nvSpPr>
@@ -2716,7 +2805,13 @@
       </p:sp>
       <p:sp>
         <p:nvSpPr>
-          <p:cNvPr id="5" name="Phase 1"/>
+          <p:cNvPr id="5" name="Phase 1" descr="">
+            <a:extLst>
+              <a:ext uri="{C183D7F6-B498-43B3-948B-1728B52AA6E4}">
+                <adec:decorative xmlns:adec="http://schemas.microsoft.com/office/drawing/2017/decorative" val="1"/>
+              </a:ext>
+            </a:extLst>
+          </p:cNvPr>
           <p:cNvSpPr/>
           <p:nvPr/>
         </p:nvSpPr>
@@ -2797,7 +2892,13 @@
       </p:sp>
       <p:sp>
         <p:nvSpPr>
-          <p:cNvPr id="7" name="Phase 2"/>
+          <p:cNvPr id="7" name="Phase 2" descr="">
+            <a:extLst>
+              <a:ext uri="{C183D7F6-B498-43B3-948B-1728B52AA6E4}">
+                <adec:decorative xmlns:adec="http://schemas.microsoft.com/office/drawing/2017/decorative" val="1"/>
+              </a:ext>
+            </a:extLst>
+          </p:cNvPr>
           <p:cNvSpPr/>
           <p:nvPr/>
         </p:nvSpPr>
@@ -2878,7 +2979,13 @@
       </p:sp>
       <p:sp>
         <p:nvSpPr>
-          <p:cNvPr id="9" name="Phase 3"/>
+          <p:cNvPr id="9" name="Phase 3" descr="">
+            <a:extLst>
+              <a:ext uri="{C183D7F6-B498-43B3-948B-1728B52AA6E4}">
+                <adec:decorative xmlns:adec="http://schemas.microsoft.com/office/drawing/2017/decorative" val="1"/>
+              </a:ext>
+            </a:extLst>
+          </p:cNvPr>
           <p:cNvSpPr/>
           <p:nvPr/>
         </p:nvSpPr>
@@ -2959,7 +3066,13 @@
       </p:sp>
       <p:sp>
         <p:nvSpPr>
-          <p:cNvPr id="11" name="Phase 4"/>
+          <p:cNvPr id="11" name="Phase 4" descr="">
+            <a:extLst>
+              <a:ext uri="{C183D7F6-B498-43B3-948B-1728B52AA6E4}">
+                <adec:decorative xmlns:adec="http://schemas.microsoft.com/office/drawing/2017/decorative" val="1"/>
+              </a:ext>
+            </a:extLst>
+          </p:cNvPr>
           <p:cNvSpPr/>
           <p:nvPr/>
         </p:nvSpPr>
@@ -3040,7 +3153,13 @@
       </p:sp>
       <p:sp>
         <p:nvSpPr>
-          <p:cNvPr id="13" name="Phase 5"/>
+          <p:cNvPr id="13" name="Phase 5" descr="">
+            <a:extLst>
+              <a:ext uri="{C183D7F6-B498-43B3-948B-1728B52AA6E4}">
+                <adec:decorative xmlns:adec="http://schemas.microsoft.com/office/drawing/2017/decorative" val="1"/>
+              </a:ext>
+            </a:extLst>
+          </p:cNvPr>
           <p:cNvSpPr/>
           <p:nvPr/>
         </p:nvSpPr>
@@ -3121,7 +3240,13 @@
       </p:sp>
       <p:sp>
         <p:nvSpPr>
-          <p:cNvPr id="15" name="Bundle box"/>
+          <p:cNvPr id="15" name="Bundle box" descr="">
+            <a:extLst>
+              <a:ext uri="{C183D7F6-B498-43B3-948B-1728B52AA6E4}">
+                <adec:decorative xmlns:adec="http://schemas.microsoft.com/office/drawing/2017/decorative" val="1"/>
+              </a:ext>
+            </a:extLst>
+          </p:cNvPr>
           <p:cNvSpPr/>
           <p:nvPr/>
         </p:nvSpPr>
@@ -3155,7 +3280,13 @@
       </p:sp>
       <p:sp>
         <p:nvSpPr>
-          <p:cNvPr id="16" name="Icon FaFileShield"/>
+          <p:cNvPr id="16" name="Icon FaFileShield" descr="">
+            <a:extLst>
+              <a:ext uri="{C183D7F6-B498-43B3-948B-1728B52AA6E4}">
+                <adec:decorative xmlns:adec="http://schemas.microsoft.com/office/drawing/2017/decorative" val="1"/>
+              </a:ext>
+            </a:extLst>
+          </p:cNvPr>
           <p:cNvSpPr/>
           <p:nvPr/>
         </p:nvSpPr>
@@ -3180,7 +3311,13 @@
       </p:sp>
       <p:pic>
         <p:nvPicPr>
-          <p:cNvPr id="17" name="Image 0" descr="C:\Users\whale\git\mwb-b02\presentations\_build\icons\FaFileShield.png">    </p:cNvPr>
+          <p:cNvPr id="17" name="Image 0" descr="">
+            <a:extLst>
+              <a:ext uri="{C183D7F6-B498-43B3-948B-1728B52AA6E4}">
+                <adec:decorative xmlns:adec="http://schemas.microsoft.com/office/drawing/2017/decorative" val="1"/>
+              </a:ext>
+            </a:extLst>
+          </p:cNvPr>
           <p:cNvPicPr>
             <a:picLocks noChangeAspect="1"/>
           </p:cNvPicPr>
@@ -3351,7 +3488,13 @@
       </p:sp>
       <p:sp>
         <p:nvSpPr>
-          <p:cNvPr id="20" name="Framing"/>
+          <p:cNvPr id="20" name="Framing" descr="">
+            <a:extLst>
+              <a:ext uri="{C183D7F6-B498-43B3-948B-1728B52AA6E4}">
+                <adec:decorative xmlns:adec="http://schemas.microsoft.com/office/drawing/2017/decorative" val="1"/>
+              </a:ext>
+            </a:extLst>
+          </p:cNvPr>
           <p:cNvSpPr/>
           <p:nvPr/>
         </p:nvSpPr>
@@ -3385,7 +3528,13 @@
       </p:sp>
       <p:sp>
         <p:nvSpPr>
-          <p:cNvPr id="21" name="Icon FaBuilding"/>
+          <p:cNvPr id="21" name="Icon FaBuilding" descr="">
+            <a:extLst>
+              <a:ext uri="{C183D7F6-B498-43B3-948B-1728B52AA6E4}">
+                <adec:decorative xmlns:adec="http://schemas.microsoft.com/office/drawing/2017/decorative" val="1"/>
+              </a:ext>
+            </a:extLst>
+          </p:cNvPr>
           <p:cNvSpPr/>
           <p:nvPr/>
         </p:nvSpPr>
@@ -3410,7 +3559,13 @@
       </p:sp>
       <p:pic>
         <p:nvPicPr>
-          <p:cNvPr id="22" name="Image 1" descr="C:\Users\whale\git\mwb-b02\presentations\_build\icons\FaBuilding.png">    </p:cNvPr>
+          <p:cNvPr id="22" name="Image 1" descr="">
+            <a:extLst>
+              <a:ext uri="{C183D7F6-B498-43B3-948B-1728B52AA6E4}">
+                <adec:decorative xmlns:adec="http://schemas.microsoft.com/office/drawing/2017/decorative" val="1"/>
+              </a:ext>
+            </a:extLst>
+          </p:cNvPr>
           <p:cNvPicPr>
             <a:picLocks noChangeAspect="1"/>
           </p:cNvPicPr>
@@ -3628,7 +3783,13 @@
       </p:sp>
       <p:sp>
         <p:nvSpPr>
-          <p:cNvPr id="3" name="Tag How"/>
+          <p:cNvPr id="3" name="Tag How" descr="">
+            <a:extLst>
+              <a:ext uri="{C183D7F6-B498-43B3-948B-1728B52AA6E4}">
+                <adec:decorative xmlns:adec="http://schemas.microsoft.com/office/drawing/2017/decorative" val="1"/>
+              </a:ext>
+            </a:extLst>
+          </p:cNvPr>
           <p:cNvSpPr/>
           <p:nvPr/>
         </p:nvSpPr>
@@ -3691,7 +3852,13 @@
       </p:sp>
       <p:sp>
         <p:nvSpPr>
-          <p:cNvPr id="5" name="Ask 1"/>
+          <p:cNvPr id="5" name="Ask 1" descr="">
+            <a:extLst>
+              <a:ext uri="{C183D7F6-B498-43B3-948B-1728B52AA6E4}">
+                <adec:decorative xmlns:adec="http://schemas.microsoft.com/office/drawing/2017/decorative" val="1"/>
+              </a:ext>
+            </a:extLst>
+          </p:cNvPr>
           <p:cNvSpPr/>
           <p:nvPr/>
         </p:nvSpPr>
@@ -3725,7 +3892,13 @@
       </p:sp>
       <p:sp>
         <p:nvSpPr>
-          <p:cNvPr id="6" name="Icon FaUserCheck"/>
+          <p:cNvPr id="6" name="Icon FaUserCheck" descr="">
+            <a:extLst>
+              <a:ext uri="{C183D7F6-B498-43B3-948B-1728B52AA6E4}">
+                <adec:decorative xmlns:adec="http://schemas.microsoft.com/office/drawing/2017/decorative" val="1"/>
+              </a:ext>
+            </a:extLst>
+          </p:cNvPr>
           <p:cNvSpPr/>
           <p:nvPr/>
         </p:nvSpPr>
@@ -3750,7 +3923,13 @@
       </p:sp>
       <p:pic>
         <p:nvPicPr>
-          <p:cNvPr id="7" name="Image 0" descr="C:\Users\whale\git\mwb-b02\presentations\_build\icons\FaUserCheck.png">    </p:cNvPr>
+          <p:cNvPr id="7" name="Image 0" descr="">
+            <a:extLst>
+              <a:ext uri="{C183D7F6-B498-43B3-948B-1728B52AA6E4}">
+                <adec:decorative xmlns:adec="http://schemas.microsoft.com/office/drawing/2017/decorative" val="1"/>
+              </a:ext>
+            </a:extLst>
+          </p:cNvPr>
           <p:cNvPicPr>
             <a:picLocks noChangeAspect="1"/>
           </p:cNvPicPr>
@@ -3827,7 +4006,13 @@
       </p:sp>
       <p:sp>
         <p:nvSpPr>
-          <p:cNvPr id="9" name="Ask 2"/>
+          <p:cNvPr id="9" name="Ask 2" descr="">
+            <a:extLst>
+              <a:ext uri="{C183D7F6-B498-43B3-948B-1728B52AA6E4}">
+                <adec:decorative xmlns:adec="http://schemas.microsoft.com/office/drawing/2017/decorative" val="1"/>
+              </a:ext>
+            </a:extLst>
+          </p:cNvPr>
           <p:cNvSpPr/>
           <p:nvPr/>
         </p:nvSpPr>
@@ -3861,7 +4046,13 @@
       </p:sp>
       <p:sp>
         <p:nvSpPr>
-          <p:cNvPr id="10" name="Icon FaListCheck"/>
+          <p:cNvPr id="10" name="Icon FaListCheck" descr="">
+            <a:extLst>
+              <a:ext uri="{C183D7F6-B498-43B3-948B-1728B52AA6E4}">
+                <adec:decorative xmlns:adec="http://schemas.microsoft.com/office/drawing/2017/decorative" val="1"/>
+              </a:ext>
+            </a:extLst>
+          </p:cNvPr>
           <p:cNvSpPr/>
           <p:nvPr/>
         </p:nvSpPr>
@@ -3886,7 +4077,13 @@
       </p:sp>
       <p:pic>
         <p:nvPicPr>
-          <p:cNvPr id="11" name="Image 1" descr="C:\Users\whale\git\mwb-b02\presentations\_build\icons\FaListCheck.png">    </p:cNvPr>
+          <p:cNvPr id="11" name="Image 1" descr="">
+            <a:extLst>
+              <a:ext uri="{C183D7F6-B498-43B3-948B-1728B52AA6E4}">
+                <adec:decorative xmlns:adec="http://schemas.microsoft.com/office/drawing/2017/decorative" val="1"/>
+              </a:ext>
+            </a:extLst>
+          </p:cNvPr>
           <p:cNvPicPr>
             <a:picLocks noChangeAspect="1"/>
           </p:cNvPicPr>
@@ -3963,7 +4160,13 @@
       </p:sp>
       <p:sp>
         <p:nvSpPr>
-          <p:cNvPr id="13" name="Ask 3"/>
+          <p:cNvPr id="13" name="Ask 3" descr="">
+            <a:extLst>
+              <a:ext uri="{C183D7F6-B498-43B3-948B-1728B52AA6E4}">
+                <adec:decorative xmlns:adec="http://schemas.microsoft.com/office/drawing/2017/decorative" val="1"/>
+              </a:ext>
+            </a:extLst>
+          </p:cNvPr>
           <p:cNvSpPr/>
           <p:nvPr/>
         </p:nvSpPr>
@@ -3997,7 +4200,13 @@
       </p:sp>
       <p:sp>
         <p:nvSpPr>
-          <p:cNvPr id="14" name="Icon FaUserClock"/>
+          <p:cNvPr id="14" name="Icon FaUserClock" descr="">
+            <a:extLst>
+              <a:ext uri="{C183D7F6-B498-43B3-948B-1728B52AA6E4}">
+                <adec:decorative xmlns:adec="http://schemas.microsoft.com/office/drawing/2017/decorative" val="1"/>
+              </a:ext>
+            </a:extLst>
+          </p:cNvPr>
           <p:cNvSpPr/>
           <p:nvPr/>
         </p:nvSpPr>
@@ -4022,7 +4231,13 @@
       </p:sp>
       <p:pic>
         <p:nvPicPr>
-          <p:cNvPr id="15" name="Image 2" descr="C:\Users\whale\git\mwb-b02\presentations\_build\icons\FaUserClock.png">    </p:cNvPr>
+          <p:cNvPr id="15" name="Image 2" descr="">
+            <a:extLst>
+              <a:ext uri="{C183D7F6-B498-43B3-948B-1728B52AA6E4}">
+                <adec:decorative xmlns:adec="http://schemas.microsoft.com/office/drawing/2017/decorative" val="1"/>
+              </a:ext>
+            </a:extLst>
+          </p:cNvPr>
           <p:cNvPicPr>
             <a:picLocks noChangeAspect="1"/>
           </p:cNvPicPr>
@@ -4099,7 +4314,13 @@
       </p:sp>
       <p:sp>
         <p:nvSpPr>
-          <p:cNvPr id="17" name="Ask 4"/>
+          <p:cNvPr id="17" name="Ask 4" descr="">
+            <a:extLst>
+              <a:ext uri="{C183D7F6-B498-43B3-948B-1728B52AA6E4}">
+                <adec:decorative xmlns:adec="http://schemas.microsoft.com/office/drawing/2017/decorative" val="1"/>
+              </a:ext>
+            </a:extLst>
+          </p:cNvPr>
           <p:cNvSpPr/>
           <p:nvPr/>
         </p:nvSpPr>
@@ -4133,7 +4354,13 @@
       </p:sp>
       <p:sp>
         <p:nvSpPr>
-          <p:cNvPr id="18" name="Icon FaFileShield"/>
+          <p:cNvPr id="18" name="Icon FaFileShield" descr="">
+            <a:extLst>
+              <a:ext uri="{C183D7F6-B498-43B3-948B-1728B52AA6E4}">
+                <adec:decorative xmlns:adec="http://schemas.microsoft.com/office/drawing/2017/decorative" val="1"/>
+              </a:ext>
+            </a:extLst>
+          </p:cNvPr>
           <p:cNvSpPr/>
           <p:nvPr/>
         </p:nvSpPr>
@@ -4158,7 +4385,13 @@
       </p:sp>
       <p:pic>
         <p:nvPicPr>
-          <p:cNvPr id="19" name="Image 3" descr="C:\Users\whale\git\mwb-b02\presentations\_build\icons\FaFileShield.png">    </p:cNvPr>
+          <p:cNvPr id="19" name="Image 3" descr="">
+            <a:extLst>
+              <a:ext uri="{C183D7F6-B498-43B3-948B-1728B52AA6E4}">
+                <adec:decorative xmlns:adec="http://schemas.microsoft.com/office/drawing/2017/decorative" val="1"/>
+              </a:ext>
+            </a:extLst>
+          </p:cNvPr>
           <p:cNvPicPr>
             <a:picLocks noChangeAspect="1"/>
           </p:cNvPicPr>
@@ -4235,7 +4468,13 @@
       </p:sp>
       <p:sp>
         <p:nvSpPr>
-          <p:cNvPr id="21" name="Close"/>
+          <p:cNvPr id="21" name="Close" descr="">
+            <a:extLst>
+              <a:ext uri="{C183D7F6-B498-43B3-948B-1728B52AA6E4}">
+                <adec:decorative xmlns:adec="http://schemas.microsoft.com/office/drawing/2017/decorative" val="1"/>
+              </a:ext>
+            </a:extLst>
+          </p:cNvPr>
           <p:cNvSpPr/>
           <p:nvPr/>
         </p:nvSpPr>
@@ -4269,7 +4508,13 @@
       </p:sp>
       <p:sp>
         <p:nvSpPr>
-          <p:cNvPr id="22" name="Icon FaBook"/>
+          <p:cNvPr id="22" name="Icon FaBook" descr="">
+            <a:extLst>
+              <a:ext uri="{C183D7F6-B498-43B3-948B-1728B52AA6E4}">
+                <adec:decorative xmlns:adec="http://schemas.microsoft.com/office/drawing/2017/decorative" val="1"/>
+              </a:ext>
+            </a:extLst>
+          </p:cNvPr>
           <p:cNvSpPr/>
           <p:nvPr/>
         </p:nvSpPr>
@@ -4294,7 +4539,13 @@
       </p:sp>
       <p:pic>
         <p:nvPicPr>
-          <p:cNvPr id="23" name="Image 4" descr="C:\Users\whale\git\mwb-b02\presentations\_build\icons\FaBook.png">    </p:cNvPr>
+          <p:cNvPr id="23" name="Image 4" descr="">
+            <a:extLst>
+              <a:ext uri="{C183D7F6-B498-43B3-948B-1728B52AA6E4}">
+                <adec:decorative xmlns:adec="http://schemas.microsoft.com/office/drawing/2017/decorative" val="1"/>
+              </a:ext>
+            </a:extLst>
+          </p:cNvPr>
           <p:cNvPicPr>
             <a:picLocks noChangeAspect="1"/>
           </p:cNvPicPr>
@@ -4936,7 +5187,13 @@
       </p:sp>
       <p:sp>
         <p:nvSpPr>
-          <p:cNvPr id="3" name="Tag Why"/>
+          <p:cNvPr id="3" name="Tag Why" descr="">
+            <a:extLst>
+              <a:ext uri="{C183D7F6-B498-43B3-948B-1728B52AA6E4}">
+                <adec:decorative xmlns:adec="http://schemas.microsoft.com/office/drawing/2017/decorative" val="1"/>
+              </a:ext>
+            </a:extLst>
+          </p:cNvPr>
           <p:cNvSpPr/>
           <p:nvPr/>
         </p:nvSpPr>
@@ -5035,7 +5292,13 @@
       </p:sp>
       <p:sp>
         <p:nvSpPr>
-          <p:cNvPr id="6" name="Icon FaLandmark"/>
+          <p:cNvPr id="6" name="Icon FaLandmark" descr="">
+            <a:extLst>
+              <a:ext uri="{C183D7F6-B498-43B3-948B-1728B52AA6E4}">
+                <adec:decorative xmlns:adec="http://schemas.microsoft.com/office/drawing/2017/decorative" val="1"/>
+              </a:ext>
+            </a:extLst>
+          </p:cNvPr>
           <p:cNvSpPr/>
           <p:nvPr/>
         </p:nvSpPr>
@@ -5060,7 +5323,13 @@
       </p:sp>
       <p:pic>
         <p:nvPicPr>
-          <p:cNvPr id="7" name="Image 0" descr="C:\Users\whale\git\mwb-b02\presentations\_build\icons\FaLandmark.png">    </p:cNvPr>
+          <p:cNvPr id="7" name="Image 0" descr="">
+            <a:extLst>
+              <a:ext uri="{C183D7F6-B498-43B3-948B-1728B52AA6E4}">
+                <adec:decorative xmlns:adec="http://schemas.microsoft.com/office/drawing/2017/decorative" val="1"/>
+              </a:ext>
+            </a:extLst>
+          </p:cNvPr>
           <p:cNvPicPr>
             <a:picLocks noChangeAspect="1"/>
           </p:cNvPicPr>
@@ -5134,7 +5403,13 @@
       </p:sp>
       <p:sp>
         <p:nvSpPr>
-          <p:cNvPr id="9" name="Icon FaBook"/>
+          <p:cNvPr id="9" name="Icon FaBook" descr="">
+            <a:extLst>
+              <a:ext uri="{C183D7F6-B498-43B3-948B-1728B52AA6E4}">
+                <adec:decorative xmlns:adec="http://schemas.microsoft.com/office/drawing/2017/decorative" val="1"/>
+              </a:ext>
+            </a:extLst>
+          </p:cNvPr>
           <p:cNvSpPr/>
           <p:nvPr/>
         </p:nvSpPr>
@@ -5159,7 +5434,13 @@
       </p:sp>
       <p:pic>
         <p:nvPicPr>
-          <p:cNvPr id="10" name="Image 1" descr="C:\Users\whale\git\mwb-b02\presentations\_build\icons\FaBook.png">    </p:cNvPr>
+          <p:cNvPr id="10" name="Image 1" descr="">
+            <a:extLst>
+              <a:ext uri="{C183D7F6-B498-43B3-948B-1728B52AA6E4}">
+                <adec:decorative xmlns:adec="http://schemas.microsoft.com/office/drawing/2017/decorative" val="1"/>
+              </a:ext>
+            </a:extLst>
+          </p:cNvPr>
           <p:cNvPicPr>
             <a:picLocks noChangeAspect="1"/>
           </p:cNvPicPr>
@@ -5233,7 +5514,13 @@
       </p:sp>
       <p:sp>
         <p:nvSpPr>
-          <p:cNvPr id="12" name="Icon FaSitemap"/>
+          <p:cNvPr id="12" name="Icon FaSitemap" descr="">
+            <a:extLst>
+              <a:ext uri="{C183D7F6-B498-43B3-948B-1728B52AA6E4}">
+                <adec:decorative xmlns:adec="http://schemas.microsoft.com/office/drawing/2017/decorative" val="1"/>
+              </a:ext>
+            </a:extLst>
+          </p:cNvPr>
           <p:cNvSpPr/>
           <p:nvPr/>
         </p:nvSpPr>
@@ -5258,7 +5545,13 @@
       </p:sp>
       <p:pic>
         <p:nvPicPr>
-          <p:cNvPr id="13" name="Image 2" descr="C:\Users\whale\git\mwb-b02\presentations\_build\icons\FaSitemap.png">    </p:cNvPr>
+          <p:cNvPr id="13" name="Image 2" descr="">
+            <a:extLst>
+              <a:ext uri="{C183D7F6-B498-43B3-948B-1728B52AA6E4}">
+                <adec:decorative xmlns:adec="http://schemas.microsoft.com/office/drawing/2017/decorative" val="1"/>
+              </a:ext>
+            </a:extLst>
+          </p:cNvPr>
           <p:cNvPicPr>
             <a:picLocks noChangeAspect="1"/>
           </p:cNvPicPr>
@@ -5332,7 +5625,13 @@
       </p:sp>
       <p:sp>
         <p:nvSpPr>
-          <p:cNvPr id="15" name="Consequence box"/>
+          <p:cNvPr id="15" name="Consequence box" descr="">
+            <a:extLst>
+              <a:ext uri="{C183D7F6-B498-43B3-948B-1728B52AA6E4}">
+                <adec:decorative xmlns:adec="http://schemas.microsoft.com/office/drawing/2017/decorative" val="1"/>
+              </a:ext>
+            </a:extLst>
+          </p:cNvPr>
           <p:cNvSpPr/>
           <p:nvPr/>
         </p:nvSpPr>
@@ -5366,7 +5665,13 @@
       </p:sp>
       <p:sp>
         <p:nvSpPr>
-          <p:cNvPr id="16" name="Icon FaIdCard"/>
+          <p:cNvPr id="16" name="Icon FaIdCard" descr="">
+            <a:extLst>
+              <a:ext uri="{C183D7F6-B498-43B3-948B-1728B52AA6E4}">
+                <adec:decorative xmlns:adec="http://schemas.microsoft.com/office/drawing/2017/decorative" val="1"/>
+              </a:ext>
+            </a:extLst>
+          </p:cNvPr>
           <p:cNvSpPr/>
           <p:nvPr/>
         </p:nvSpPr>
@@ -5391,7 +5696,13 @@
       </p:sp>
       <p:pic>
         <p:nvPicPr>
-          <p:cNvPr id="17" name="Image 3" descr="C:\Users\whale\git\mwb-b02\presentations\_build\icons\FaIdCard.png">    </p:cNvPr>
+          <p:cNvPr id="17" name="Image 3" descr="">
+            <a:extLst>
+              <a:ext uri="{C183D7F6-B498-43B3-948B-1728B52AA6E4}">
+                <adec:decorative xmlns:adec="http://schemas.microsoft.com/office/drawing/2017/decorative" val="1"/>
+              </a:ext>
+            </a:extLst>
+          </p:cNvPr>
           <p:cNvPicPr>
             <a:picLocks noChangeAspect="1"/>
           </p:cNvPicPr>
@@ -5580,7 +5891,13 @@
       </p:sp>
       <p:sp>
         <p:nvSpPr>
-          <p:cNvPr id="21" name="Not an upgrade"/>
+          <p:cNvPr id="21" name="Not an upgrade" descr="">
+            <a:extLst>
+              <a:ext uri="{C183D7F6-B498-43B3-948B-1728B52AA6E4}">
+                <adec:decorative xmlns:adec="http://schemas.microsoft.com/office/drawing/2017/decorative" val="1"/>
+              </a:ext>
+            </a:extLst>
+          </p:cNvPr>
           <p:cNvSpPr/>
           <p:nvPr/>
         </p:nvSpPr>
@@ -5614,7 +5931,13 @@
       </p:sp>
       <p:sp>
         <p:nvSpPr>
-          <p:cNvPr id="22" name="Icon FaTriangleExclamation"/>
+          <p:cNvPr id="22" name="Icon FaTriangleExclamation" descr="">
+            <a:extLst>
+              <a:ext uri="{C183D7F6-B498-43B3-948B-1728B52AA6E4}">
+                <adec:decorative xmlns:adec="http://schemas.microsoft.com/office/drawing/2017/decorative" val="1"/>
+              </a:ext>
+            </a:extLst>
+          </p:cNvPr>
           <p:cNvSpPr/>
           <p:nvPr/>
         </p:nvSpPr>
@@ -5639,7 +5962,13 @@
       </p:sp>
       <p:pic>
         <p:nvPicPr>
-          <p:cNvPr id="23" name="Image 4" descr="C:\Users\whale\git\mwb-b02\presentations\_build\icons\FaTriangleExclamation.png">    </p:cNvPr>
+          <p:cNvPr id="23" name="Image 4" descr="">
+            <a:extLst>
+              <a:ext uri="{C183D7F6-B498-43B3-948B-1728B52AA6E4}">
+                <adec:decorative xmlns:adec="http://schemas.microsoft.com/office/drawing/2017/decorative" val="1"/>
+              </a:ext>
+            </a:extLst>
+          </p:cNvPr>
           <p:cNvPicPr>
             <a:picLocks noChangeAspect="1"/>
           </p:cNvPicPr>
@@ -5857,7 +6186,13 @@
       </p:sp>
       <p:sp>
         <p:nvSpPr>
-          <p:cNvPr id="3" name="Tag Why"/>
+          <p:cNvPr id="3" name="Tag Why" descr="">
+            <a:extLst>
+              <a:ext uri="{C183D7F6-B498-43B3-948B-1728B52AA6E4}">
+                <adec:decorative xmlns:adec="http://schemas.microsoft.com/office/drawing/2017/decorative" val="1"/>
+              </a:ext>
+            </a:extLst>
+          </p:cNvPr>
           <p:cNvSpPr/>
           <p:nvPr/>
         </p:nvSpPr>
@@ -5920,7 +6255,13 @@
       </p:sp>
       <p:sp>
         <p:nvSpPr>
-          <p:cNvPr id="5" name="Date 1"/>
+          <p:cNvPr id="5" name="Date 1" descr="">
+            <a:extLst>
+              <a:ext uri="{C183D7F6-B498-43B3-948B-1728B52AA6E4}">
+                <adec:decorative xmlns:adec="http://schemas.microsoft.com/office/drawing/2017/decorative" val="1"/>
+              </a:ext>
+            </a:extLst>
+          </p:cNvPr>
           <p:cNvSpPr/>
           <p:nvPr/>
         </p:nvSpPr>
@@ -6013,7 +6354,13 @@
       </p:sp>
       <p:sp>
         <p:nvSpPr>
-          <p:cNvPr id="7" name="Date 2"/>
+          <p:cNvPr id="7" name="Date 2" descr="">
+            <a:extLst>
+              <a:ext uri="{C183D7F6-B498-43B3-948B-1728B52AA6E4}">
+                <adec:decorative xmlns:adec="http://schemas.microsoft.com/office/drawing/2017/decorative" val="1"/>
+              </a:ext>
+            </a:extLst>
+          </p:cNvPr>
           <p:cNvSpPr/>
           <p:nvPr/>
         </p:nvSpPr>
@@ -6106,7 +6453,13 @@
       </p:sp>
       <p:sp>
         <p:nvSpPr>
-          <p:cNvPr id="9" name="Date 3"/>
+          <p:cNvPr id="9" name="Date 3" descr="">
+            <a:extLst>
+              <a:ext uri="{C183D7F6-B498-43B3-948B-1728B52AA6E4}">
+                <adec:decorative xmlns:adec="http://schemas.microsoft.com/office/drawing/2017/decorative" val="1"/>
+              </a:ext>
+            </a:extLst>
+          </p:cNvPr>
           <p:cNvSpPr/>
           <p:nvPr/>
         </p:nvSpPr>
@@ -6199,7 +6552,13 @@
       </p:sp>
       <p:sp>
         <p:nvSpPr>
-          <p:cNvPr id="11" name="Date 4"/>
+          <p:cNvPr id="11" name="Date 4" descr="">
+            <a:extLst>
+              <a:ext uri="{C183D7F6-B498-43B3-948B-1728B52AA6E4}">
+                <adec:decorative xmlns:adec="http://schemas.microsoft.com/office/drawing/2017/decorative" val="1"/>
+              </a:ext>
+            </a:extLst>
+          </p:cNvPr>
           <p:cNvSpPr/>
           <p:nvPr/>
         </p:nvSpPr>
@@ -6339,7 +6698,13 @@
       </p:sp>
       <p:sp>
         <p:nvSpPr>
-          <p:cNvPr id="14" name="Lift and shift"/>
+          <p:cNvPr id="14" name="Lift and shift" descr="">
+            <a:extLst>
+              <a:ext uri="{C183D7F6-B498-43B3-948B-1728B52AA6E4}">
+                <adec:decorative xmlns:adec="http://schemas.microsoft.com/office/drawing/2017/decorative" val="1"/>
+              </a:ext>
+            </a:extLst>
+          </p:cNvPr>
           <p:cNvSpPr/>
           <p:nvPr/>
         </p:nvSpPr>
@@ -6373,7 +6738,13 @@
       </p:sp>
       <p:sp>
         <p:nvSpPr>
-          <p:cNvPr id="15" name="Icon FaPlugCircleXmark"/>
+          <p:cNvPr id="15" name="Icon FaPlugCircleXmark" descr="">
+            <a:extLst>
+              <a:ext uri="{C183D7F6-B498-43B3-948B-1728B52AA6E4}">
+                <adec:decorative xmlns:adec="http://schemas.microsoft.com/office/drawing/2017/decorative" val="1"/>
+              </a:ext>
+            </a:extLst>
+          </p:cNvPr>
           <p:cNvSpPr/>
           <p:nvPr/>
         </p:nvSpPr>
@@ -6398,7 +6769,13 @@
       </p:sp>
       <p:pic>
         <p:nvPicPr>
-          <p:cNvPr id="16" name="Image 0" descr="C:\Users\whale\git\mwb-b02\presentations\_build\icons\FaPlugCircleXmark.png">    </p:cNvPr>
+          <p:cNvPr id="16" name="Image 0" descr="">
+            <a:extLst>
+              <a:ext uri="{C183D7F6-B498-43B3-948B-1728B52AA6E4}">
+                <adec:decorative xmlns:adec="http://schemas.microsoft.com/office/drawing/2017/decorative" val="1"/>
+              </a:ext>
+            </a:extLst>
+          </p:cNvPr>
           <p:cNvPicPr>
             <a:picLocks noChangeAspect="1"/>
           </p:cNvPicPr>
@@ -6616,7 +6993,13 @@
       </p:sp>
       <p:sp>
         <p:nvSpPr>
-          <p:cNvPr id="3" name="Tag What"/>
+          <p:cNvPr id="3" name="Tag What" descr="">
+            <a:extLst>
+              <a:ext uri="{C183D7F6-B498-43B3-948B-1728B52AA6E4}">
+                <adec:decorative xmlns:adec="http://schemas.microsoft.com/office/drawing/2017/decorative" val="1"/>
+              </a:ext>
+            </a:extLst>
+          </p:cNvPr>
           <p:cNvSpPr/>
           <p:nvPr/>
         </p:nvSpPr>
@@ -6698,7 +7081,7 @@
         <a:graphic>
           <a:graphicData uri="http://schemas.openxmlformats.org/drawingml/2006/table">
             <a:tbl>
-              <a:tblPr/>
+              <a:tblPr firstRow="1" bandRow="1"/>
               <a:tblGrid>
                 <a:gridCol w="1965960"/>
                 <a:gridCol w="4206240"/>
@@ -8141,7 +8524,13 @@
       </p:graphicFrame>
       <p:sp>
         <p:nvSpPr>
-          <p:cNvPr id="6" name="Key idea"/>
+          <p:cNvPr id="6" name="Key idea" descr="">
+            <a:extLst>
+              <a:ext uri="{C183D7F6-B498-43B3-948B-1728B52AA6E4}">
+                <adec:decorative xmlns:adec="http://schemas.microsoft.com/office/drawing/2017/decorative" val="1"/>
+              </a:ext>
+            </a:extLst>
+          </p:cNvPr>
           <p:cNvSpPr/>
           <p:nvPr/>
         </p:nvSpPr>
@@ -8175,7 +8564,13 @@
       </p:sp>
       <p:sp>
         <p:nvSpPr>
-          <p:cNvPr id="7" name="Icon FaRightLeft"/>
+          <p:cNvPr id="7" name="Icon FaRightLeft" descr="">
+            <a:extLst>
+              <a:ext uri="{C183D7F6-B498-43B3-948B-1728B52AA6E4}">
+                <adec:decorative xmlns:adec="http://schemas.microsoft.com/office/drawing/2017/decorative" val="1"/>
+              </a:ext>
+            </a:extLst>
+          </p:cNvPr>
           <p:cNvSpPr/>
           <p:nvPr/>
         </p:nvSpPr>
@@ -8200,7 +8595,13 @@
       </p:sp>
       <p:pic>
         <p:nvPicPr>
-          <p:cNvPr id="8" name="Image 0" descr="C:\Users\whale\git\mwb-b02\presentations\_build\icons\FaRightLeft.png">    </p:cNvPr>
+          <p:cNvPr id="8" name="Image 0" descr="">
+            <a:extLst>
+              <a:ext uri="{C183D7F6-B498-43B3-948B-1728B52AA6E4}">
+                <adec:decorative xmlns:adec="http://schemas.microsoft.com/office/drawing/2017/decorative" val="1"/>
+              </a:ext>
+            </a:extLst>
+          </p:cNvPr>
           <p:cNvPicPr>
             <a:picLocks noChangeAspect="1"/>
           </p:cNvPicPr>
@@ -8418,7 +8819,13 @@
       </p:sp>
       <p:sp>
         <p:nvSpPr>
-          <p:cNvPr id="3" name="Tag What"/>
+          <p:cNvPr id="3" name="Tag What" descr="">
+            <a:extLst>
+              <a:ext uri="{C183D7F6-B498-43B3-948B-1728B52AA6E4}">
+                <adec:decorative xmlns:adec="http://schemas.microsoft.com/office/drawing/2017/decorative" val="1"/>
+              </a:ext>
+            </a:extLst>
+          </p:cNvPr>
           <p:cNvSpPr/>
           <p:nvPr/>
         </p:nvSpPr>
@@ -8517,7 +8924,13 @@
       </p:sp>
       <p:sp>
         <p:nvSpPr>
-          <p:cNvPr id="6" name="Dep 1"/>
+          <p:cNvPr id="6" name="Dep 1" descr="">
+            <a:extLst>
+              <a:ext uri="{C183D7F6-B498-43B3-948B-1728B52AA6E4}">
+                <adec:decorative xmlns:adec="http://schemas.microsoft.com/office/drawing/2017/decorative" val="1"/>
+              </a:ext>
+            </a:extLst>
+          </p:cNvPr>
           <p:cNvSpPr/>
           <p:nvPr/>
         </p:nvSpPr>
@@ -8551,7 +8964,13 @@
       </p:sp>
       <p:sp>
         <p:nvSpPr>
-          <p:cNvPr id="7" name="Icon FaGlobe"/>
+          <p:cNvPr id="7" name="Icon FaGlobe" descr="">
+            <a:extLst>
+              <a:ext uri="{C183D7F6-B498-43B3-948B-1728B52AA6E4}">
+                <adec:decorative xmlns:adec="http://schemas.microsoft.com/office/drawing/2017/decorative" val="1"/>
+              </a:ext>
+            </a:extLst>
+          </p:cNvPr>
           <p:cNvSpPr/>
           <p:nvPr/>
         </p:nvSpPr>
@@ -8576,7 +8995,13 @@
       </p:sp>
       <p:pic>
         <p:nvPicPr>
-          <p:cNvPr id="8" name="Image 0" descr="C:\Users\whale\git\mwb-b02\presentations\_build\icons\FaGlobe.png">    </p:cNvPr>
+          <p:cNvPr id="8" name="Image 0" descr="">
+            <a:extLst>
+              <a:ext uri="{C183D7F6-B498-43B3-948B-1728B52AA6E4}">
+                <adec:decorative xmlns:adec="http://schemas.microsoft.com/office/drawing/2017/decorative" val="1"/>
+              </a:ext>
+            </a:extLst>
+          </p:cNvPr>
           <p:cNvPicPr>
             <a:picLocks noChangeAspect="1"/>
           </p:cNvPicPr>
@@ -8650,7 +9075,13 @@
       </p:sp>
       <p:sp>
         <p:nvSpPr>
-          <p:cNvPr id="10" name="Dep 2"/>
+          <p:cNvPr id="10" name="Dep 2" descr="">
+            <a:extLst>
+              <a:ext uri="{C183D7F6-B498-43B3-948B-1728B52AA6E4}">
+                <adec:decorative xmlns:adec="http://schemas.microsoft.com/office/drawing/2017/decorative" val="1"/>
+              </a:ext>
+            </a:extLst>
+          </p:cNvPr>
           <p:cNvSpPr/>
           <p:nvPr/>
         </p:nvSpPr>
@@ -8684,7 +9115,13 @@
       </p:sp>
       <p:sp>
         <p:nvSpPr>
-          <p:cNvPr id="11" name="Icon FaKey"/>
+          <p:cNvPr id="11" name="Icon FaKey" descr="">
+            <a:extLst>
+              <a:ext uri="{C183D7F6-B498-43B3-948B-1728B52AA6E4}">
+                <adec:decorative xmlns:adec="http://schemas.microsoft.com/office/drawing/2017/decorative" val="1"/>
+              </a:ext>
+            </a:extLst>
+          </p:cNvPr>
           <p:cNvSpPr/>
           <p:nvPr/>
         </p:nvSpPr>
@@ -8709,7 +9146,13 @@
       </p:sp>
       <p:pic>
         <p:nvPicPr>
-          <p:cNvPr id="12" name="Image 1" descr="C:\Users\whale\git\mwb-b02\presentations\_build\icons\FaKey.png">    </p:cNvPr>
+          <p:cNvPr id="12" name="Image 1" descr="">
+            <a:extLst>
+              <a:ext uri="{C183D7F6-B498-43B3-948B-1728B52AA6E4}">
+                <adec:decorative xmlns:adec="http://schemas.microsoft.com/office/drawing/2017/decorative" val="1"/>
+              </a:ext>
+            </a:extLst>
+          </p:cNvPr>
           <p:cNvPicPr>
             <a:picLocks noChangeAspect="1"/>
           </p:cNvPicPr>
@@ -8783,7 +9226,13 @@
       </p:sp>
       <p:sp>
         <p:nvSpPr>
-          <p:cNvPr id="14" name="Dep 3"/>
+          <p:cNvPr id="14" name="Dep 3" descr="">
+            <a:extLst>
+              <a:ext uri="{C183D7F6-B498-43B3-948B-1728B52AA6E4}">
+                <adec:decorative xmlns:adec="http://schemas.microsoft.com/office/drawing/2017/decorative" val="1"/>
+              </a:ext>
+            </a:extLst>
+          </p:cNvPr>
           <p:cNvSpPr/>
           <p:nvPr/>
         </p:nvSpPr>
@@ -8817,7 +9266,13 @@
       </p:sp>
       <p:sp>
         <p:nvSpPr>
-          <p:cNvPr id="15" name="Icon FaRoute"/>
+          <p:cNvPr id="15" name="Icon FaRoute" descr="">
+            <a:extLst>
+              <a:ext uri="{C183D7F6-B498-43B3-948B-1728B52AA6E4}">
+                <adec:decorative xmlns:adec="http://schemas.microsoft.com/office/drawing/2017/decorative" val="1"/>
+              </a:ext>
+            </a:extLst>
+          </p:cNvPr>
           <p:cNvSpPr/>
           <p:nvPr/>
         </p:nvSpPr>
@@ -8842,7 +9297,13 @@
       </p:sp>
       <p:pic>
         <p:nvPicPr>
-          <p:cNvPr id="16" name="Image 2" descr="C:\Users\whale\git\mwb-b02\presentations\_build\icons\FaRoute.png">    </p:cNvPr>
+          <p:cNvPr id="16" name="Image 2" descr="">
+            <a:extLst>
+              <a:ext uri="{C183D7F6-B498-43B3-948B-1728B52AA6E4}">
+                <adec:decorative xmlns:adec="http://schemas.microsoft.com/office/drawing/2017/decorative" val="1"/>
+              </a:ext>
+            </a:extLst>
+          </p:cNvPr>
           <p:cNvPicPr>
             <a:picLocks noChangeAspect="1"/>
           </p:cNvPicPr>
@@ -8916,7 +9377,13 @@
       </p:sp>
       <p:sp>
         <p:nvSpPr>
-          <p:cNvPr id="18" name="Dep 4"/>
+          <p:cNvPr id="18" name="Dep 4" descr="">
+            <a:extLst>
+              <a:ext uri="{C183D7F6-B498-43B3-948B-1728B52AA6E4}">
+                <adec:decorative xmlns:adec="http://schemas.microsoft.com/office/drawing/2017/decorative" val="1"/>
+              </a:ext>
+            </a:extLst>
+          </p:cNvPr>
           <p:cNvSpPr/>
           <p:nvPr/>
         </p:nvSpPr>
@@ -8950,7 +9417,13 @@
       </p:sp>
       <p:sp>
         <p:nvSpPr>
-          <p:cNvPr id="19" name="Icon FaPlugCircleXmark"/>
+          <p:cNvPr id="19" name="Icon FaPlugCircleXmark" descr="">
+            <a:extLst>
+              <a:ext uri="{C183D7F6-B498-43B3-948B-1728B52AA6E4}">
+                <adec:decorative xmlns:adec="http://schemas.microsoft.com/office/drawing/2017/decorative" val="1"/>
+              </a:ext>
+            </a:extLst>
+          </p:cNvPr>
           <p:cNvSpPr/>
           <p:nvPr/>
         </p:nvSpPr>
@@ -8975,7 +9448,13 @@
       </p:sp>
       <p:pic>
         <p:nvPicPr>
-          <p:cNvPr id="20" name="Image 3" descr="C:\Users\whale\git\mwb-b02\presentations\_build\icons\FaPlugCircleXmark.png">    </p:cNvPr>
+          <p:cNvPr id="20" name="Image 3" descr="">
+            <a:extLst>
+              <a:ext uri="{C183D7F6-B498-43B3-948B-1728B52AA6E4}">
+                <adec:decorative xmlns:adec="http://schemas.microsoft.com/office/drawing/2017/decorative" val="1"/>
+              </a:ext>
+            </a:extLst>
+          </p:cNvPr>
           <p:cNvPicPr>
             <a:picLocks noChangeAspect="1"/>
           </p:cNvPicPr>
@@ -9049,7 +9528,13 @@
       </p:sp>
       <p:sp>
         <p:nvSpPr>
-          <p:cNvPr id="22" name="Dep 5"/>
+          <p:cNvPr id="22" name="Dep 5" descr="">
+            <a:extLst>
+              <a:ext uri="{C183D7F6-B498-43B3-948B-1728B52AA6E4}">
+                <adec:decorative xmlns:adec="http://schemas.microsoft.com/office/drawing/2017/decorative" val="1"/>
+              </a:ext>
+            </a:extLst>
+          </p:cNvPr>
           <p:cNvSpPr/>
           <p:nvPr/>
         </p:nvSpPr>
@@ -9083,7 +9568,13 @@
       </p:sp>
       <p:sp>
         <p:nvSpPr>
-          <p:cNvPr id="23" name="Icon FaArrowsRotate"/>
+          <p:cNvPr id="23" name="Icon FaArrowsRotate" descr="">
+            <a:extLst>
+              <a:ext uri="{C183D7F6-B498-43B3-948B-1728B52AA6E4}">
+                <adec:decorative xmlns:adec="http://schemas.microsoft.com/office/drawing/2017/decorative" val="1"/>
+              </a:ext>
+            </a:extLst>
+          </p:cNvPr>
           <p:cNvSpPr/>
           <p:nvPr/>
         </p:nvSpPr>
@@ -9108,7 +9599,13 @@
       </p:sp>
       <p:pic>
         <p:nvPicPr>
-          <p:cNvPr id="24" name="Image 4" descr="C:\Users\whale\git\mwb-b02\presentations\_build\icons\FaArrowsRotate.png">    </p:cNvPr>
+          <p:cNvPr id="24" name="Image 4" descr="">
+            <a:extLst>
+              <a:ext uri="{C183D7F6-B498-43B3-948B-1728B52AA6E4}">
+                <adec:decorative xmlns:adec="http://schemas.microsoft.com/office/drawing/2017/decorative" val="1"/>
+              </a:ext>
+            </a:extLst>
+          </p:cNvPr>
           <p:cNvPicPr>
             <a:picLocks noChangeAspect="1"/>
           </p:cNvPicPr>
@@ -9182,7 +9679,13 @@
       </p:sp>
       <p:sp>
         <p:nvSpPr>
-          <p:cNvPr id="26" name="Dep 6"/>
+          <p:cNvPr id="26" name="Dep 6" descr="">
+            <a:extLst>
+              <a:ext uri="{C183D7F6-B498-43B3-948B-1728B52AA6E4}">
+                <adec:decorative xmlns:adec="http://schemas.microsoft.com/office/drawing/2017/decorative" val="1"/>
+              </a:ext>
+            </a:extLst>
+          </p:cNvPr>
           <p:cNvSpPr/>
           <p:nvPr/>
         </p:nvSpPr>
@@ -9216,7 +9719,13 @@
       </p:sp>
       <p:sp>
         <p:nvSpPr>
-          <p:cNvPr id="27" name="Icon FaLaptop"/>
+          <p:cNvPr id="27" name="Icon FaLaptop" descr="">
+            <a:extLst>
+              <a:ext uri="{C183D7F6-B498-43B3-948B-1728B52AA6E4}">
+                <adec:decorative xmlns:adec="http://schemas.microsoft.com/office/drawing/2017/decorative" val="1"/>
+              </a:ext>
+            </a:extLst>
+          </p:cNvPr>
           <p:cNvSpPr/>
           <p:nvPr/>
         </p:nvSpPr>
@@ -9241,7 +9750,13 @@
       </p:sp>
       <p:pic>
         <p:nvPicPr>
-          <p:cNvPr id="28" name="Image 5" descr="C:\Users\whale\git\mwb-b02\presentations\_build\icons\FaLaptop.png">    </p:cNvPr>
+          <p:cNvPr id="28" name="Image 5" descr="">
+            <a:extLst>
+              <a:ext uri="{C183D7F6-B498-43B3-948B-1728B52AA6E4}">
+                <adec:decorative xmlns:adec="http://schemas.microsoft.com/office/drawing/2017/decorative" val="1"/>
+              </a:ext>
+            </a:extLst>
+          </p:cNvPr>
           <p:cNvPicPr>
             <a:picLocks noChangeAspect="1"/>
           </p:cNvPicPr>
@@ -9315,7 +9830,13 @@
       </p:sp>
       <p:sp>
         <p:nvSpPr>
-          <p:cNvPr id="30" name="Dep 7"/>
+          <p:cNvPr id="30" name="Dep 7" descr="">
+            <a:extLst>
+              <a:ext uri="{C183D7F6-B498-43B3-948B-1728B52AA6E4}">
+                <adec:decorative xmlns:adec="http://schemas.microsoft.com/office/drawing/2017/decorative" val="1"/>
+              </a:ext>
+            </a:extLst>
+          </p:cNvPr>
           <p:cNvSpPr/>
           <p:nvPr/>
         </p:nvSpPr>
@@ -9349,7 +9870,13 @@
       </p:sp>
       <p:sp>
         <p:nvSpPr>
-          <p:cNvPr id="31" name="Icon FaUserClock"/>
+          <p:cNvPr id="31" name="Icon FaUserClock" descr="">
+            <a:extLst>
+              <a:ext uri="{C183D7F6-B498-43B3-948B-1728B52AA6E4}">
+                <adec:decorative xmlns:adec="http://schemas.microsoft.com/office/drawing/2017/decorative" val="1"/>
+              </a:ext>
+            </a:extLst>
+          </p:cNvPr>
           <p:cNvSpPr/>
           <p:nvPr/>
         </p:nvSpPr>
@@ -9374,7 +9901,13 @@
       </p:sp>
       <p:pic>
         <p:nvPicPr>
-          <p:cNvPr id="32" name="Image 6" descr="C:\Users\whale\git\mwb-b02\presentations\_build\icons\FaUserClock.png">    </p:cNvPr>
+          <p:cNvPr id="32" name="Image 6" descr="">
+            <a:extLst>
+              <a:ext uri="{C183D7F6-B498-43B3-948B-1728B52AA6E4}">
+                <adec:decorative xmlns:adec="http://schemas.microsoft.com/office/drawing/2017/decorative" val="1"/>
+              </a:ext>
+            </a:extLst>
+          </p:cNvPr>
           <p:cNvPicPr>
             <a:picLocks noChangeAspect="1"/>
           </p:cNvPicPr>
@@ -9448,7 +9981,13 @@
       </p:sp>
       <p:sp>
         <p:nvSpPr>
-          <p:cNvPr id="34" name="Dep 8"/>
+          <p:cNvPr id="34" name="Dep 8" descr="">
+            <a:extLst>
+              <a:ext uri="{C183D7F6-B498-43B3-948B-1728B52AA6E4}">
+                <adec:decorative xmlns:adec="http://schemas.microsoft.com/office/drawing/2017/decorative" val="1"/>
+              </a:ext>
+            </a:extLst>
+          </p:cNvPr>
           <p:cNvSpPr/>
           <p:nvPr/>
         </p:nvSpPr>
@@ -9482,7 +10021,13 @@
       </p:sp>
       <p:sp>
         <p:nvSpPr>
-          <p:cNvPr id="35" name="Icon FaDatabase"/>
+          <p:cNvPr id="35" name="Icon FaDatabase" descr="">
+            <a:extLst>
+              <a:ext uri="{C183D7F6-B498-43B3-948B-1728B52AA6E4}">
+                <adec:decorative xmlns:adec="http://schemas.microsoft.com/office/drawing/2017/decorative" val="1"/>
+              </a:ext>
+            </a:extLst>
+          </p:cNvPr>
           <p:cNvSpPr/>
           <p:nvPr/>
         </p:nvSpPr>
@@ -9507,7 +10052,13 @@
       </p:sp>
       <p:pic>
         <p:nvPicPr>
-          <p:cNvPr id="36" name="Image 7" descr="C:\Users\whale\git\mwb-b02\presentations\_build\icons\FaDatabase.png">    </p:cNvPr>
+          <p:cNvPr id="36" name="Image 7" descr="">
+            <a:extLst>
+              <a:ext uri="{C183D7F6-B498-43B3-948B-1728B52AA6E4}">
+                <adec:decorative xmlns:adec="http://schemas.microsoft.com/office/drawing/2017/decorative" val="1"/>
+              </a:ext>
+            </a:extLst>
+          </p:cNvPr>
           <p:cNvPicPr>
             <a:picLocks noChangeAspect="1"/>
           </p:cNvPicPr>
@@ -9581,7 +10132,13 @@
       </p:sp>
       <p:sp>
         <p:nvSpPr>
-          <p:cNvPr id="38" name="Adapters"/>
+          <p:cNvPr id="38" name="Adapters" descr="">
+            <a:extLst>
+              <a:ext uri="{C183D7F6-B498-43B3-948B-1728B52AA6E4}">
+                <adec:decorative xmlns:adec="http://schemas.microsoft.com/office/drawing/2017/decorative" val="1"/>
+              </a:ext>
+            </a:extLst>
+          </p:cNvPr>
           <p:cNvSpPr/>
           <p:nvPr/>
         </p:nvSpPr>
@@ -9615,7 +10172,13 @@
       </p:sp>
       <p:sp>
         <p:nvSpPr>
-          <p:cNvPr id="39" name="Icon FaCubes"/>
+          <p:cNvPr id="39" name="Icon FaCubes" descr="">
+            <a:extLst>
+              <a:ext uri="{C183D7F6-B498-43B3-948B-1728B52AA6E4}">
+                <adec:decorative xmlns:adec="http://schemas.microsoft.com/office/drawing/2017/decorative" val="1"/>
+              </a:ext>
+            </a:extLst>
+          </p:cNvPr>
           <p:cNvSpPr/>
           <p:nvPr/>
         </p:nvSpPr>
@@ -9640,7 +10203,13 @@
       </p:sp>
       <p:pic>
         <p:nvPicPr>
-          <p:cNvPr id="40" name="Image 8" descr="C:\Users\whale\git\mwb-b02\presentations\_build\icons\FaCubes.png">    </p:cNvPr>
+          <p:cNvPr id="40" name="Image 8" descr="">
+            <a:extLst>
+              <a:ext uri="{C183D7F6-B498-43B3-948B-1728B52AA6E4}">
+                <adec:decorative xmlns:adec="http://schemas.microsoft.com/office/drawing/2017/decorative" val="1"/>
+              </a:ext>
+            </a:extLst>
+          </p:cNvPr>
           <p:cNvPicPr>
             <a:picLocks noChangeAspect="1"/>
           </p:cNvPicPr>
@@ -9858,7 +10427,13 @@
       </p:sp>
       <p:sp>
         <p:nvSpPr>
-          <p:cNvPr id="3" name="Tag What"/>
+          <p:cNvPr id="3" name="Tag What" descr="">
+            <a:extLst>
+              <a:ext uri="{C183D7F6-B498-43B3-948B-1728B52AA6E4}">
+                <adec:decorative xmlns:adec="http://schemas.microsoft.com/office/drawing/2017/decorative" val="1"/>
+              </a:ext>
+            </a:extLst>
+          </p:cNvPr>
           <p:cNvSpPr/>
           <p:nvPr/>
         </p:nvSpPr>
@@ -9921,7 +10496,13 @@
       </p:sp>
       <p:sp>
         <p:nvSpPr>
-          <p:cNvPr id="5" name="Tier 0"/>
+          <p:cNvPr id="5" name="Tier 0" descr="">
+            <a:extLst>
+              <a:ext uri="{C183D7F6-B498-43B3-948B-1728B52AA6E4}">
+                <adec:decorative xmlns:adec="http://schemas.microsoft.com/office/drawing/2017/decorative" val="1"/>
+              </a:ext>
+            </a:extLst>
+          </p:cNvPr>
           <p:cNvSpPr/>
           <p:nvPr/>
         </p:nvSpPr>
@@ -10005,7 +10586,13 @@
       </p:sp>
       <p:sp>
         <p:nvSpPr>
-          <p:cNvPr id="7" name="Tier 1"/>
+          <p:cNvPr id="7" name="Tier 1" descr="">
+            <a:extLst>
+              <a:ext uri="{C183D7F6-B498-43B3-948B-1728B52AA6E4}">
+                <adec:decorative xmlns:adec="http://schemas.microsoft.com/office/drawing/2017/decorative" val="1"/>
+              </a:ext>
+            </a:extLst>
+          </p:cNvPr>
           <p:cNvSpPr/>
           <p:nvPr/>
         </p:nvSpPr>
@@ -10089,7 +10676,13 @@
       </p:sp>
       <p:sp>
         <p:nvSpPr>
-          <p:cNvPr id="9" name="Tier 2"/>
+          <p:cNvPr id="9" name="Tier 2" descr="">
+            <a:extLst>
+              <a:ext uri="{C183D7F6-B498-43B3-948B-1728B52AA6E4}">
+                <adec:decorative xmlns:adec="http://schemas.microsoft.com/office/drawing/2017/decorative" val="1"/>
+              </a:ext>
+            </a:extLst>
+          </p:cNvPr>
           <p:cNvSpPr/>
           <p:nvPr/>
         </p:nvSpPr>
@@ -10173,7 +10766,13 @@
       </p:sp>
       <p:sp>
         <p:nvSpPr>
-          <p:cNvPr id="11" name="Facts box"/>
+          <p:cNvPr id="11" name="Facts box" descr="">
+            <a:extLst>
+              <a:ext uri="{C183D7F6-B498-43B3-948B-1728B52AA6E4}">
+                <adec:decorative xmlns:adec="http://schemas.microsoft.com/office/drawing/2017/decorative" val="1"/>
+              </a:ext>
+            </a:extLst>
+          </p:cNvPr>
           <p:cNvSpPr/>
           <p:nvPr/>
         </p:nvSpPr>
@@ -10337,7 +10936,13 @@
       </p:sp>
       <p:sp>
         <p:nvSpPr>
-          <p:cNvPr id="14" name="Decision"/>
+          <p:cNvPr id="14" name="Decision" descr="">
+            <a:extLst>
+              <a:ext uri="{C183D7F6-B498-43B3-948B-1728B52AA6E4}">
+                <adec:decorative xmlns:adec="http://schemas.microsoft.com/office/drawing/2017/decorative" val="1"/>
+              </a:ext>
+            </a:extLst>
+          </p:cNvPr>
           <p:cNvSpPr/>
           <p:nvPr/>
         </p:nvSpPr>
@@ -10371,7 +10976,13 @@
       </p:sp>
       <p:sp>
         <p:nvSpPr>
-          <p:cNvPr id="15" name="Icon FaScaleBalanced"/>
+          <p:cNvPr id="15" name="Icon FaScaleBalanced" descr="">
+            <a:extLst>
+              <a:ext uri="{C183D7F6-B498-43B3-948B-1728B52AA6E4}">
+                <adec:decorative xmlns:adec="http://schemas.microsoft.com/office/drawing/2017/decorative" val="1"/>
+              </a:ext>
+            </a:extLst>
+          </p:cNvPr>
           <p:cNvSpPr/>
           <p:nvPr/>
         </p:nvSpPr>
@@ -10396,7 +11007,13 @@
       </p:sp>
       <p:pic>
         <p:nvPicPr>
-          <p:cNvPr id="16" name="Image 0" descr="C:\Users\whale\git\mwb-b02\presentations\_build\icons\FaScaleBalanced.png">    </p:cNvPr>
+          <p:cNvPr id="16" name="Image 0" descr="">
+            <a:extLst>
+              <a:ext uri="{C183D7F6-B498-43B3-948B-1728B52AA6E4}">
+                <adec:decorative xmlns:adec="http://schemas.microsoft.com/office/drawing/2017/decorative" val="1"/>
+              </a:ext>
+            </a:extLst>
+          </p:cNvPr>
           <p:cNvPicPr>
             <a:picLocks noChangeAspect="1"/>
           </p:cNvPicPr>
@@ -10614,7 +11231,13 @@
       </p:sp>
       <p:sp>
         <p:nvSpPr>
-          <p:cNvPr id="3" name="Tag What"/>
+          <p:cNvPr id="3" name="Tag What" descr="">
+            <a:extLst>
+              <a:ext uri="{C183D7F6-B498-43B3-948B-1728B52AA6E4}">
+                <adec:decorative xmlns:adec="http://schemas.microsoft.com/office/drawing/2017/decorative" val="1"/>
+              </a:ext>
+            </a:extLst>
+          </p:cNvPr>
           <p:cNvSpPr/>
           <p:nvPr/>
         </p:nvSpPr>
@@ -10696,7 +11319,7 @@
         <a:graphic>
           <a:graphicData uri="http://schemas.openxmlformats.org/drawingml/2006/table">
             <a:tbl>
-              <a:tblPr/>
+              <a:tblPr firstRow="1" bandRow="1"/>
               <a:tblGrid>
                 <a:gridCol w="777240"/>
                 <a:gridCol w="2377440"/>
@@ -11738,7 +12361,13 @@
       </p:graphicFrame>
       <p:sp>
         <p:nvSpPr>
-          <p:cNvPr id="6" name="Off box"/>
+          <p:cNvPr id="6" name="Off box" descr="">
+            <a:extLst>
+              <a:ext uri="{C183D7F6-B498-43B3-948B-1728B52AA6E4}">
+                <adec:decorative xmlns:adec="http://schemas.microsoft.com/office/drawing/2017/decorative" val="1"/>
+              </a:ext>
+            </a:extLst>
+          </p:cNvPr>
           <p:cNvSpPr/>
           <p:nvPr/>
         </p:nvSpPr>
@@ -11772,7 +12401,13 @@
       </p:sp>
       <p:sp>
         <p:nvSpPr>
-          <p:cNvPr id="7" name="Icon FaLock"/>
+          <p:cNvPr id="7" name="Icon FaLock" descr="">
+            <a:extLst>
+              <a:ext uri="{C183D7F6-B498-43B3-948B-1728B52AA6E4}">
+                <adec:decorative xmlns:adec="http://schemas.microsoft.com/office/drawing/2017/decorative" val="1"/>
+              </a:ext>
+            </a:extLst>
+          </p:cNvPr>
           <p:cNvSpPr/>
           <p:nvPr/>
         </p:nvSpPr>
@@ -11797,7 +12432,13 @@
       </p:sp>
       <p:pic>
         <p:nvPicPr>
-          <p:cNvPr id="8" name="Image 0" descr="C:\Users\whale\git\mwb-b02\presentations\_build\icons\FaLock.png">    </p:cNvPr>
+          <p:cNvPr id="8" name="Image 0" descr="">
+            <a:extLst>
+              <a:ext uri="{C183D7F6-B498-43B3-948B-1728B52AA6E4}">
+                <adec:decorative xmlns:adec="http://schemas.microsoft.com/office/drawing/2017/decorative" val="1"/>
+              </a:ext>
+            </a:extLst>
+          </p:cNvPr>
           <p:cNvPicPr>
             <a:picLocks noChangeAspect="1"/>
           </p:cNvPicPr>
@@ -11950,7 +12591,13 @@
       </p:sp>
       <p:sp>
         <p:nvSpPr>
-          <p:cNvPr id="11" name="PHS"/>
+          <p:cNvPr id="11" name="PHS" descr="">
+            <a:extLst>
+              <a:ext uri="{C183D7F6-B498-43B3-948B-1728B52AA6E4}">
+                <adec:decorative xmlns:adec="http://schemas.microsoft.com/office/drawing/2017/decorative" val="1"/>
+              </a:ext>
+            </a:extLst>
+          </p:cNvPr>
           <p:cNvSpPr/>
           <p:nvPr/>
         </p:nvSpPr>
@@ -11984,7 +12631,13 @@
       </p:sp>
       <p:sp>
         <p:nvSpPr>
-          <p:cNvPr id="12" name="Icon FaKey"/>
+          <p:cNvPr id="12" name="Icon FaKey" descr="">
+            <a:extLst>
+              <a:ext uri="{C183D7F6-B498-43B3-948B-1728B52AA6E4}">
+                <adec:decorative xmlns:adec="http://schemas.microsoft.com/office/drawing/2017/decorative" val="1"/>
+              </a:ext>
+            </a:extLst>
+          </p:cNvPr>
           <p:cNvSpPr/>
           <p:nvPr/>
         </p:nvSpPr>
@@ -12009,7 +12662,13 @@
       </p:sp>
       <p:pic>
         <p:nvPicPr>
-          <p:cNvPr id="13" name="Image 1" descr="C:\Users\whale\git\mwb-b02\presentations\_build\icons\FaKey.png">    </p:cNvPr>
+          <p:cNvPr id="13" name="Image 1" descr="">
+            <a:extLst>
+              <a:ext uri="{C183D7F6-B498-43B3-948B-1728B52AA6E4}">
+                <adec:decorative xmlns:adec="http://schemas.microsoft.com/office/drawing/2017/decorative" val="1"/>
+              </a:ext>
+            </a:extLst>
+          </p:cNvPr>
           <p:cNvPicPr>
             <a:picLocks noChangeAspect="1"/>
           </p:cNvPicPr>
@@ -12227,7 +12886,13 @@
       </p:sp>
       <p:sp>
         <p:nvSpPr>
-          <p:cNvPr id="3" name="Tag Who"/>
+          <p:cNvPr id="3" name="Tag Who" descr="">
+            <a:extLst>
+              <a:ext uri="{C183D7F6-B498-43B3-948B-1728B52AA6E4}">
+                <adec:decorative xmlns:adec="http://schemas.microsoft.com/office/drawing/2017/decorative" val="1"/>
+              </a:ext>
+            </a:extLst>
+          </p:cNvPr>
           <p:cNvSpPr/>
           <p:nvPr/>
         </p:nvSpPr>
@@ -12290,7 +12955,13 @@
       </p:sp>
       <p:sp>
         <p:nvSpPr>
-          <p:cNvPr id="5" name="Who col 1"/>
+          <p:cNvPr id="5" name="Who col 1" descr="">
+            <a:extLst>
+              <a:ext uri="{C183D7F6-B498-43B3-948B-1728B52AA6E4}">
+                <adec:decorative xmlns:adec="http://schemas.microsoft.com/office/drawing/2017/decorative" val="1"/>
+              </a:ext>
+            </a:extLst>
+          </p:cNvPr>
           <p:cNvSpPr/>
           <p:nvPr/>
         </p:nvSpPr>
@@ -12324,7 +12995,13 @@
       </p:sp>
       <p:sp>
         <p:nvSpPr>
-          <p:cNvPr id="6" name="Icon FaBuildingColumns"/>
+          <p:cNvPr id="6" name="Icon FaBuildingColumns" descr="">
+            <a:extLst>
+              <a:ext uri="{C183D7F6-B498-43B3-948B-1728B52AA6E4}">
+                <adec:decorative xmlns:adec="http://schemas.microsoft.com/office/drawing/2017/decorative" val="1"/>
+              </a:ext>
+            </a:extLst>
+          </p:cNvPr>
           <p:cNvSpPr/>
           <p:nvPr/>
         </p:nvSpPr>
@@ -12349,7 +13026,13 @@
       </p:sp>
       <p:pic>
         <p:nvPicPr>
-          <p:cNvPr id="7" name="Image 0" descr="C:\Users\whale\git\mwb-b02\presentations\_build\icons\FaBuildingColumns.png">    </p:cNvPr>
+          <p:cNvPr id="7" name="Image 0" descr="">
+            <a:extLst>
+              <a:ext uri="{C183D7F6-B498-43B3-948B-1728B52AA6E4}">
+                <adec:decorative xmlns:adec="http://schemas.microsoft.com/office/drawing/2017/decorative" val="1"/>
+              </a:ext>
+            </a:extLst>
+          </p:cNvPr>
           <p:cNvPicPr>
             <a:picLocks noChangeAspect="1"/>
           </p:cNvPicPr>
@@ -12536,7 +13219,13 @@
       </p:sp>
       <p:sp>
         <p:nvSpPr>
-          <p:cNvPr id="10" name="Who col 2"/>
+          <p:cNvPr id="10" name="Who col 2" descr="">
+            <a:extLst>
+              <a:ext uri="{C183D7F6-B498-43B3-948B-1728B52AA6E4}">
+                <adec:decorative xmlns:adec="http://schemas.microsoft.com/office/drawing/2017/decorative" val="1"/>
+              </a:ext>
+            </a:extLst>
+          </p:cNvPr>
           <p:cNvSpPr/>
           <p:nvPr/>
         </p:nvSpPr>
@@ -12570,7 +13259,13 @@
       </p:sp>
       <p:sp>
         <p:nvSpPr>
-          <p:cNvPr id="11" name="Icon FaUsersGear"/>
+          <p:cNvPr id="11" name="Icon FaUsersGear" descr="">
+            <a:extLst>
+              <a:ext uri="{C183D7F6-B498-43B3-948B-1728B52AA6E4}">
+                <adec:decorative xmlns:adec="http://schemas.microsoft.com/office/drawing/2017/decorative" val="1"/>
+              </a:ext>
+            </a:extLst>
+          </p:cNvPr>
           <p:cNvSpPr/>
           <p:nvPr/>
         </p:nvSpPr>
@@ -12595,7 +13290,13 @@
       </p:sp>
       <p:pic>
         <p:nvPicPr>
-          <p:cNvPr id="12" name="Image 1" descr="C:\Users\whale\git\mwb-b02\presentations\_build\icons\FaUsersGear.png">    </p:cNvPr>
+          <p:cNvPr id="12" name="Image 1" descr="">
+            <a:extLst>
+              <a:ext uri="{C183D7F6-B498-43B3-948B-1728B52AA6E4}">
+                <adec:decorative xmlns:adec="http://schemas.microsoft.com/office/drawing/2017/decorative" val="1"/>
+              </a:ext>
+            </a:extLst>
+          </p:cNvPr>
           <p:cNvPicPr>
             <a:picLocks noChangeAspect="1"/>
           </p:cNvPicPr>
@@ -12782,7 +13483,13 @@
       </p:sp>
       <p:sp>
         <p:nvSpPr>
-          <p:cNvPr id="15" name="Who col 3"/>
+          <p:cNvPr id="15" name="Who col 3" descr="">
+            <a:extLst>
+              <a:ext uri="{C183D7F6-B498-43B3-948B-1728B52AA6E4}">
+                <adec:decorative xmlns:adec="http://schemas.microsoft.com/office/drawing/2017/decorative" val="1"/>
+              </a:ext>
+            </a:extLst>
+          </p:cNvPr>
           <p:cNvSpPr/>
           <p:nvPr/>
         </p:nvSpPr>
@@ -12816,7 +13523,13 @@
       </p:sp>
       <p:sp>
         <p:nvSpPr>
-          <p:cNvPr id="16" name="Icon FaPeopleArrows"/>
+          <p:cNvPr id="16" name="Icon FaPeopleArrows" descr="">
+            <a:extLst>
+              <a:ext uri="{C183D7F6-B498-43B3-948B-1728B52AA6E4}">
+                <adec:decorative xmlns:adec="http://schemas.microsoft.com/office/drawing/2017/decorative" val="1"/>
+              </a:ext>
+            </a:extLst>
+          </p:cNvPr>
           <p:cNvSpPr/>
           <p:nvPr/>
         </p:nvSpPr>
@@ -12841,7 +13554,13 @@
       </p:sp>
       <p:pic>
         <p:nvPicPr>
-          <p:cNvPr id="17" name="Image 2" descr="C:\Users\whale\git\mwb-b02\presentations\_build\icons\FaPeopleArrows.png">    </p:cNvPr>
+          <p:cNvPr id="17" name="Image 2" descr="">
+            <a:extLst>
+              <a:ext uri="{C183D7F6-B498-43B3-948B-1728B52AA6E4}">
+                <adec:decorative xmlns:adec="http://schemas.microsoft.com/office/drawing/2017/decorative" val="1"/>
+              </a:ext>
+            </a:extLst>
+          </p:cNvPr>
           <p:cNvPicPr>
             <a:picLocks noChangeAspect="1"/>
           </p:cNvPicPr>
@@ -13028,7 +13747,13 @@
       </p:sp>
       <p:sp>
         <p:nvSpPr>
-          <p:cNvPr id="20" name="Gap owner"/>
+          <p:cNvPr id="20" name="Gap owner" descr="">
+            <a:extLst>
+              <a:ext uri="{C183D7F6-B498-43B3-948B-1728B52AA6E4}">
+                <adec:decorative xmlns:adec="http://schemas.microsoft.com/office/drawing/2017/decorative" val="1"/>
+              </a:ext>
+            </a:extLst>
+          </p:cNvPr>
           <p:cNvSpPr/>
           <p:nvPr/>
         </p:nvSpPr>
@@ -13062,7 +13787,13 @@
       </p:sp>
       <p:sp>
         <p:nvSpPr>
-          <p:cNvPr id="21" name="Icon FaSitemap"/>
+          <p:cNvPr id="21" name="Icon FaSitemap" descr="">
+            <a:extLst>
+              <a:ext uri="{C183D7F6-B498-43B3-948B-1728B52AA6E4}">
+                <adec:decorative xmlns:adec="http://schemas.microsoft.com/office/drawing/2017/decorative" val="1"/>
+              </a:ext>
+            </a:extLst>
+          </p:cNvPr>
           <p:cNvSpPr/>
           <p:nvPr/>
         </p:nvSpPr>
@@ -13087,7 +13818,13 @@
       </p:sp>
       <p:pic>
         <p:nvPicPr>
-          <p:cNvPr id="22" name="Image 3" descr="C:\Users\whale\git\mwb-b02\presentations\_build\icons\FaSitemap.png">    </p:cNvPr>
+          <p:cNvPr id="22" name="Image 3" descr="">
+            <a:extLst>
+              <a:ext uri="{C183D7F6-B498-43B3-948B-1728B52AA6E4}">
+                <adec:decorative xmlns:adec="http://schemas.microsoft.com/office/drawing/2017/decorative" val="1"/>
+              </a:ext>
+            </a:extLst>
+          </p:cNvPr>
           <p:cNvPicPr>
             <a:picLocks noChangeAspect="1"/>
           </p:cNvPicPr>
@@ -13305,7 +14042,13 @@
       </p:sp>
       <p:sp>
         <p:nvSpPr>
-          <p:cNvPr id="3" name="Tag How"/>
+          <p:cNvPr id="3" name="Tag How" descr="">
+            <a:extLst>
+              <a:ext uri="{C183D7F6-B498-43B3-948B-1728B52AA6E4}">
+                <adec:decorative xmlns:adec="http://schemas.microsoft.com/office/drawing/2017/decorative" val="1"/>
+              </a:ext>
+            </a:extLst>
+          </p:cNvPr>
           <p:cNvSpPr/>
           <p:nvPr/>
         </p:nvSpPr>
@@ -13368,7 +14111,13 @@
       </p:sp>
       <p:sp>
         <p:nvSpPr>
-          <p:cNvPr id="5" name="Step 1"/>
+          <p:cNvPr id="5" name="Step 1" descr="">
+            <a:extLst>
+              <a:ext uri="{C183D7F6-B498-43B3-948B-1728B52AA6E4}">
+                <adec:decorative xmlns:adec="http://schemas.microsoft.com/office/drawing/2017/decorative" val="1"/>
+              </a:ext>
+            </a:extLst>
+          </p:cNvPr>
           <p:cNvSpPr/>
           <p:nvPr/>
         </p:nvSpPr>
@@ -13517,7 +14266,13 @@
       </p:sp>
       <p:sp>
         <p:nvSpPr>
-          <p:cNvPr id="8" name="Step 2"/>
+          <p:cNvPr id="8" name="Step 2" descr="">
+            <a:extLst>
+              <a:ext uri="{C183D7F6-B498-43B3-948B-1728B52AA6E4}">
+                <adec:decorative xmlns:adec="http://schemas.microsoft.com/office/drawing/2017/decorative" val="1"/>
+              </a:ext>
+            </a:extLst>
+          </p:cNvPr>
           <p:cNvSpPr/>
           <p:nvPr/>
         </p:nvSpPr>
@@ -13666,7 +14421,13 @@
       </p:sp>
       <p:sp>
         <p:nvSpPr>
-          <p:cNvPr id="11" name="Step 3"/>
+          <p:cNvPr id="11" name="Step 3" descr="">
+            <a:extLst>
+              <a:ext uri="{C183D7F6-B498-43B3-948B-1728B52AA6E4}">
+                <adec:decorative xmlns:adec="http://schemas.microsoft.com/office/drawing/2017/decorative" val="1"/>
+              </a:ext>
+            </a:extLst>
+          </p:cNvPr>
           <p:cNvSpPr/>
           <p:nvPr/>
         </p:nvSpPr>
@@ -13815,7 +14576,13 @@
       </p:sp>
       <p:sp>
         <p:nvSpPr>
-          <p:cNvPr id="14" name="Step 4"/>
+          <p:cNvPr id="14" name="Step 4" descr="">
+            <a:extLst>
+              <a:ext uri="{C183D7F6-B498-43B3-948B-1728B52AA6E4}">
+                <adec:decorative xmlns:adec="http://schemas.microsoft.com/office/drawing/2017/decorative" val="1"/>
+              </a:ext>
+            </a:extLst>
+          </p:cNvPr>
           <p:cNvSpPr/>
           <p:nvPr/>
         </p:nvSpPr>
@@ -13964,7 +14731,13 @@
       </p:sp>
       <p:sp>
         <p:nvSpPr>
-          <p:cNvPr id="17" name="Step 5"/>
+          <p:cNvPr id="17" name="Step 5" descr="">
+            <a:extLst>
+              <a:ext uri="{C183D7F6-B498-43B3-948B-1728B52AA6E4}">
+                <adec:decorative xmlns:adec="http://schemas.microsoft.com/office/drawing/2017/decorative" val="1"/>
+              </a:ext>
+            </a:extLst>
+          </p:cNvPr>
           <p:cNvSpPr/>
           <p:nvPr/>
         </p:nvSpPr>
@@ -14113,7 +14886,13 @@
       </p:sp>
       <p:sp>
         <p:nvSpPr>
-          <p:cNvPr id="20" name="Rules"/>
+          <p:cNvPr id="20" name="Rules" descr="">
+            <a:extLst>
+              <a:ext uri="{C183D7F6-B498-43B3-948B-1728B52AA6E4}">
+                <adec:decorative xmlns:adec="http://schemas.microsoft.com/office/drawing/2017/decorative" val="1"/>
+              </a:ext>
+            </a:extLst>
+          </p:cNvPr>
           <p:cNvSpPr/>
           <p:nvPr/>
         </p:nvSpPr>
@@ -14147,7 +14926,13 @@
       </p:sp>
       <p:sp>
         <p:nvSpPr>
-          <p:cNvPr id="21" name="Icon FaClipboardCheck"/>
+          <p:cNvPr id="21" name="Icon FaClipboardCheck" descr="">
+            <a:extLst>
+              <a:ext uri="{C183D7F6-B498-43B3-948B-1728B52AA6E4}">
+                <adec:decorative xmlns:adec="http://schemas.microsoft.com/office/drawing/2017/decorative" val="1"/>
+              </a:ext>
+            </a:extLst>
+          </p:cNvPr>
           <p:cNvSpPr/>
           <p:nvPr/>
         </p:nvSpPr>
@@ -14172,7 +14957,13 @@
       </p:sp>
       <p:pic>
         <p:nvPicPr>
-          <p:cNvPr id="22" name="Image 0" descr="C:\Users\whale\git\mwb-b02\presentations\_build\icons\FaClipboardCheck.png">    </p:cNvPr>
+          <p:cNvPr id="22" name="Image 0" descr="">
+            <a:extLst>
+              <a:ext uri="{C183D7F6-B498-43B3-948B-1728B52AA6E4}">
+                <adec:decorative xmlns:adec="http://schemas.microsoft.com/office/drawing/2017/decorative" val="1"/>
+              </a:ext>
+            </a:extLst>
+          </p:cNvPr>
           <p:cNvPicPr>
             <a:picLocks noChangeAspect="1"/>
           </p:cNvPicPr>
@@ -14331,9 +15122,9 @@
 </file>
 
 <file path=ppt/theme/theme1.xml><?xml version="1.0" encoding="utf-8"?>
-<a:theme xmlns:a="http://schemas.openxmlformats.org/drawingml/2006/main" name="Modernization Workbook">
+<a:theme xmlns:a="http://schemas.openxmlformats.org/drawingml/2006/main" name="Federal Modernization Workbook">
   <a:themeElements>
-    <a:clrScheme name="Modernization Workbook">
+    <a:clrScheme name="Federal Modernization Workbook">
       <a:dk1>
         <a:srgbClr val="1F2A44"/>
       </a:dk1>
@@ -14371,7 +15162,7 @@
         <a:srgbClr val="334155"/>
       </a:folHlink>
     </a:clrScheme>
-    <a:fontScheme name="Modernization Workbook">
+    <a:fontScheme name="Federal Modernization Workbook">
       <a:majorFont>
         <a:latin typeface="Cambria"/>
         <a:ea typeface=""/>

</xml_diff>

<commit_message>
presentations: captions, accessibility pass and presenter name on every deck (#74)
* presentations: accessibility pass, captions, presenter name (wip)

* presentations: captioned narrated decks for Books 02-08 (wip)

* presentations: Book 09 narrated deck, Presentations page captions and accessibility
</commit_message>
<xml_diff>
--- a/presentations/b02-identity/B02_Identity.pptx
+++ b/presentations/b02-identity/B02_Identity.pptx
@@ -119,14 +119,14 @@
   <p:extLst>
     <p:ext uri="{521415D9-36F7-43E2-AB2F-B90AF26B5E84}">
       <p14:sectionLst xmlns:p14="http://schemas.microsoft.com/office/powerpoint/2010/main">
-        <p14:section name="Why identity matters" id="{36b658b9-63e0-0b5b-0be2-a89fc06b46f9}">
+        <p14:section name="Why identity matters" id="{252d397d-f72b-6d7a-7c8d-65f278d89d7e}">
           <p14:sldIdLst>
             <p14:sldId id="256"/>
             <p14:sldId id="257"/>
             <p14:sldId id="258"/>
           </p14:sldIdLst>
         </p14:section>
-        <p14:section name="What changes" id="{ab1d69bd-30c9-c07e-f211-fd3127e8a71d}">
+        <p14:section name="What changes" id="{55052109-6183-7980-b9ce-aa6e0993bc8c}">
           <p14:sldIdLst>
             <p14:sldId id="259"/>
             <p14:sldId id="260"/>
@@ -134,19 +134,19 @@
             <p14:sldId id="262"/>
           </p14:sldIdLst>
         </p14:section>
-        <p14:section name="Who owns it" id="{88d589cd-7428-5ac1-c542-92fc8e6e5e4f}">
+        <p14:section name="Who owns it" id="{f2a4c398-c262-7b73-f8d9-8ba02308393d}">
           <p14:sldIdLst>
             <p14:sldId id="263"/>
           </p14:sldIdLst>
         </p14:section>
-        <p14:section name="How to do it" id="{f2df7bcd-7e6e-2685-7605-eb5db27c59d9}">
+        <p14:section name="How to do it" id="{fb486a26-0329-f58a-ba66-8cba11cfd0e4}">
           <p14:sldIdLst>
             <p14:sldId id="264"/>
             <p14:sldId id="265"/>
             <p14:sldId id="266"/>
           </p14:sldIdLst>
         </p14:section>
-        <p14:section name="Backup" id="{e0a784e4-1f72-8198-80d8-b40e0aa8fedc}">
+        <p14:section name="Backup" id="{47bd790a-5004-4587-2bc3-d31c63dfd5aa}">
           <p14:sldIdLst>
             <p14:sldId id="267"/>
             <p14:sldId id="268"/>
@@ -556,7 +556,7 @@
           <a:p>
             <a:r>
               <a:rPr lang="en-US" dirty="0"/>
-              <a:t>[0:00–0:29]  This briefing comes from Book 02 of the Modernization Workbook, Identity and Directory: the move from Active Directory to Entra ID.
+              <a:t>[0:00–0:29]  This briefing comes from Book 02 of the Federal Modernization Workbook, Identity and Directory: the move from Active Directory to Entra ID.
 I'll take it through four questions. Why identity matters now. What actually changes when a directory moves to the cloud. Who has to own which decisions. And how to do it without losing the governance that twenty-five years of Active Directory quietly carried.
 The short version: this is not a directory upgrade. It decides whether every security control after it works.
 Workbook: Book 02, index.</a:t>
@@ -1954,7 +1954,7 @@
                   <a:schemeClr val="accent5"/>
                 </a:solidFill>
               </a:rPr>
-              <a:t>Modernization Workbook  ·  Book 02 Identity &amp; Directory</a:t>
+              <a:t>Federal Modernization Workbook  ·  Book 02 Identity &amp; Directory</a:t>
             </a:r>
             <a:endParaRPr lang="en-US" sz="1000" dirty="0"/>
           </a:p>
@@ -2435,7 +2435,90 @@
       </p:sp>
       <p:sp>
         <p:nvSpPr>
-          <p:cNvPr id="4" name="Agenda line"/>
+          <p:cNvPr id="4" name="Presenter"/>
+          <p:cNvSpPr txBox="1"/>
+          <p:nvPr/>
+        </p:nvSpPr>
+        <p:spPr>
+          <a:xfrm>
+            <a:off x="731520" y="5897880"/>
+            <a:ext cx="6858000" cy="365760"/>
+          </a:xfrm>
+          <a:prstGeom prst="rect">
+            <a:avLst/>
+          </a:prstGeom>
+          <a:noFill/>
+          <a:ln/>
+        </p:spPr>
+        <p:txBody>
+          <a:bodyPr wrap="square" lIns="0" tIns="0" rIns="0" bIns="0" rtlCol="0" anchor="ctr"/>
+          <a:lstStyle/>
+          <a:p>
+            <a:pPr indent="0" marL="0">
+              <a:buNone/>
+            </a:pPr>
+            <a:r>
+              <a:rPr lang="en-US" sz="1600" dirty="0">
+                <a:solidFill>
+                  <a:srgbClr val="64748B"/>
+                </a:solidFill>
+              </a:rPr>
+              <a:t>Presented by  </a:t>
+            </a:r>
+            <a:pPr indent="0" marL="0">
+              <a:buNone/>
+            </a:pPr>
+            <a:r>
+              <a:rPr lang="en-US" sz="1600" b="1" dirty="0">
+                <a:solidFill>
+                  <a:srgbClr val="1F2A44"/>
+                </a:solidFill>
+              </a:rPr>
+              <a:t>Michael F. Stratton</a:t>
+            </a:r>
+            <a:endParaRPr lang="en-US" sz="1600" dirty="0"/>
+          </a:p>
+        </p:txBody>
+      </p:sp>
+      <p:sp>
+        <p:nvSpPr>
+          <p:cNvPr id="5" name="Disclaimer"/>
+          <p:cNvSpPr txBox="1"/>
+          <p:nvPr/>
+        </p:nvSpPr>
+        <p:spPr>
+          <a:xfrm>
+            <a:off x="731520" y="6309360"/>
+            <a:ext cx="8686800" cy="274320"/>
+          </a:xfrm>
+          <a:prstGeom prst="rect">
+            <a:avLst/>
+          </a:prstGeom>
+          <a:noFill/>
+          <a:ln/>
+        </p:spPr>
+        <p:txBody>
+          <a:bodyPr wrap="square" lIns="0" tIns="0" rIns="0" bIns="0" rtlCol="0" anchor="ctr"/>
+          <a:lstStyle/>
+          <a:p>
+            <a:pPr indent="0" marL="0">
+              <a:buNone/>
+            </a:pPr>
+            <a:r>
+              <a:rPr lang="en-US" sz="1050" dirty="0">
+                <a:solidFill>
+                  <a:srgbClr val="64748B"/>
+                </a:solidFill>
+              </a:rPr>
+              <a:t>Not an official U.S. government publication. Independent technical analysis; not reviewed or endorsed by any federal agency.</a:t>
+            </a:r>
+            <a:endParaRPr lang="en-US" sz="1050" dirty="0"/>
+          </a:p>
+        </p:txBody>
+      </p:sp>
+      <p:sp>
+        <p:nvSpPr>
+          <p:cNvPr id="6" name="Agenda line"/>
           <p:cNvSpPr txBox="1"/>
           <p:nvPr/>
         </p:nvSpPr>
@@ -2537,7 +2620,7 @@
       </p:sp>
       <p:sp>
         <p:nvSpPr>
-          <p:cNvPr id="5" name="Series line"/>
+          <p:cNvPr id="7" name="Series line"/>
           <p:cNvSpPr txBox="1"/>
           <p:nvPr/>
         </p:nvSpPr>
@@ -2565,7 +2648,7 @@
                   <a:srgbClr val="1F2A44"/>
                 </a:solidFill>
               </a:rPr>
-              <a:t>Modernization Workbook</a:t>
+              <a:t>Federal Modernization Workbook</a:t>
             </a:r>
             <a:endParaRPr lang="en-US" sz="1600" dirty="0"/>
           </a:p>
@@ -2653,7 +2736,13 @@
       </p:sp>
       <p:sp>
         <p:nvSpPr>
-          <p:cNvPr id="3" name="Tag How"/>
+          <p:cNvPr id="3" name="Tag How" descr="">
+            <a:extLst>
+              <a:ext uri="{C183D7F6-B498-43B3-948B-1728B52AA6E4}">
+                <adec:decorative xmlns:adec="http://schemas.microsoft.com/office/drawing/2017/decorative" val="1"/>
+              </a:ext>
+            </a:extLst>
+          </p:cNvPr>
           <p:cNvSpPr/>
           <p:nvPr/>
         </p:nvSpPr>
@@ -2716,7 +2805,13 @@
       </p:sp>
       <p:sp>
         <p:nvSpPr>
-          <p:cNvPr id="5" name="Phase 1"/>
+          <p:cNvPr id="5" name="Phase 1" descr="">
+            <a:extLst>
+              <a:ext uri="{C183D7F6-B498-43B3-948B-1728B52AA6E4}">
+                <adec:decorative xmlns:adec="http://schemas.microsoft.com/office/drawing/2017/decorative" val="1"/>
+              </a:ext>
+            </a:extLst>
+          </p:cNvPr>
           <p:cNvSpPr/>
           <p:nvPr/>
         </p:nvSpPr>
@@ -2797,7 +2892,13 @@
       </p:sp>
       <p:sp>
         <p:nvSpPr>
-          <p:cNvPr id="7" name="Phase 2"/>
+          <p:cNvPr id="7" name="Phase 2" descr="">
+            <a:extLst>
+              <a:ext uri="{C183D7F6-B498-43B3-948B-1728B52AA6E4}">
+                <adec:decorative xmlns:adec="http://schemas.microsoft.com/office/drawing/2017/decorative" val="1"/>
+              </a:ext>
+            </a:extLst>
+          </p:cNvPr>
           <p:cNvSpPr/>
           <p:nvPr/>
         </p:nvSpPr>
@@ -2878,7 +2979,13 @@
       </p:sp>
       <p:sp>
         <p:nvSpPr>
-          <p:cNvPr id="9" name="Phase 3"/>
+          <p:cNvPr id="9" name="Phase 3" descr="">
+            <a:extLst>
+              <a:ext uri="{C183D7F6-B498-43B3-948B-1728B52AA6E4}">
+                <adec:decorative xmlns:adec="http://schemas.microsoft.com/office/drawing/2017/decorative" val="1"/>
+              </a:ext>
+            </a:extLst>
+          </p:cNvPr>
           <p:cNvSpPr/>
           <p:nvPr/>
         </p:nvSpPr>
@@ -2959,7 +3066,13 @@
       </p:sp>
       <p:sp>
         <p:nvSpPr>
-          <p:cNvPr id="11" name="Phase 4"/>
+          <p:cNvPr id="11" name="Phase 4" descr="">
+            <a:extLst>
+              <a:ext uri="{C183D7F6-B498-43B3-948B-1728B52AA6E4}">
+                <adec:decorative xmlns:adec="http://schemas.microsoft.com/office/drawing/2017/decorative" val="1"/>
+              </a:ext>
+            </a:extLst>
+          </p:cNvPr>
           <p:cNvSpPr/>
           <p:nvPr/>
         </p:nvSpPr>
@@ -3040,7 +3153,13 @@
       </p:sp>
       <p:sp>
         <p:nvSpPr>
-          <p:cNvPr id="13" name="Phase 5"/>
+          <p:cNvPr id="13" name="Phase 5" descr="">
+            <a:extLst>
+              <a:ext uri="{C183D7F6-B498-43B3-948B-1728B52AA6E4}">
+                <adec:decorative xmlns:adec="http://schemas.microsoft.com/office/drawing/2017/decorative" val="1"/>
+              </a:ext>
+            </a:extLst>
+          </p:cNvPr>
           <p:cNvSpPr/>
           <p:nvPr/>
         </p:nvSpPr>
@@ -3121,7 +3240,13 @@
       </p:sp>
       <p:sp>
         <p:nvSpPr>
-          <p:cNvPr id="15" name="Bundle box"/>
+          <p:cNvPr id="15" name="Bundle box" descr="">
+            <a:extLst>
+              <a:ext uri="{C183D7F6-B498-43B3-948B-1728B52AA6E4}">
+                <adec:decorative xmlns:adec="http://schemas.microsoft.com/office/drawing/2017/decorative" val="1"/>
+              </a:ext>
+            </a:extLst>
+          </p:cNvPr>
           <p:cNvSpPr/>
           <p:nvPr/>
         </p:nvSpPr>
@@ -3155,7 +3280,13 @@
       </p:sp>
       <p:sp>
         <p:nvSpPr>
-          <p:cNvPr id="16" name="Icon FaFileShield"/>
+          <p:cNvPr id="16" name="Icon FaFileShield" descr="">
+            <a:extLst>
+              <a:ext uri="{C183D7F6-B498-43B3-948B-1728B52AA6E4}">
+                <adec:decorative xmlns:adec="http://schemas.microsoft.com/office/drawing/2017/decorative" val="1"/>
+              </a:ext>
+            </a:extLst>
+          </p:cNvPr>
           <p:cNvSpPr/>
           <p:nvPr/>
         </p:nvSpPr>
@@ -3180,7 +3311,13 @@
       </p:sp>
       <p:pic>
         <p:nvPicPr>
-          <p:cNvPr id="17" name="Image 0" descr="C:\Users\whale\git\mwb-b02\presentations\_build\icons\FaFileShield.png">    </p:cNvPr>
+          <p:cNvPr id="17" name="Image 0" descr="">
+            <a:extLst>
+              <a:ext uri="{C183D7F6-B498-43B3-948B-1728B52AA6E4}">
+                <adec:decorative xmlns:adec="http://schemas.microsoft.com/office/drawing/2017/decorative" val="1"/>
+              </a:ext>
+            </a:extLst>
+          </p:cNvPr>
           <p:cNvPicPr>
             <a:picLocks noChangeAspect="1"/>
           </p:cNvPicPr>
@@ -3351,7 +3488,13 @@
       </p:sp>
       <p:sp>
         <p:nvSpPr>
-          <p:cNvPr id="20" name="Framing"/>
+          <p:cNvPr id="20" name="Framing" descr="">
+            <a:extLst>
+              <a:ext uri="{C183D7F6-B498-43B3-948B-1728B52AA6E4}">
+                <adec:decorative xmlns:adec="http://schemas.microsoft.com/office/drawing/2017/decorative" val="1"/>
+              </a:ext>
+            </a:extLst>
+          </p:cNvPr>
           <p:cNvSpPr/>
           <p:nvPr/>
         </p:nvSpPr>
@@ -3385,7 +3528,13 @@
       </p:sp>
       <p:sp>
         <p:nvSpPr>
-          <p:cNvPr id="21" name="Icon FaBuilding"/>
+          <p:cNvPr id="21" name="Icon FaBuilding" descr="">
+            <a:extLst>
+              <a:ext uri="{C183D7F6-B498-43B3-948B-1728B52AA6E4}">
+                <adec:decorative xmlns:adec="http://schemas.microsoft.com/office/drawing/2017/decorative" val="1"/>
+              </a:ext>
+            </a:extLst>
+          </p:cNvPr>
           <p:cNvSpPr/>
           <p:nvPr/>
         </p:nvSpPr>
@@ -3410,7 +3559,13 @@
       </p:sp>
       <p:pic>
         <p:nvPicPr>
-          <p:cNvPr id="22" name="Image 1" descr="C:\Users\whale\git\mwb-b02\presentations\_build\icons\FaBuilding.png">    </p:cNvPr>
+          <p:cNvPr id="22" name="Image 1" descr="">
+            <a:extLst>
+              <a:ext uri="{C183D7F6-B498-43B3-948B-1728B52AA6E4}">
+                <adec:decorative xmlns:adec="http://schemas.microsoft.com/office/drawing/2017/decorative" val="1"/>
+              </a:ext>
+            </a:extLst>
+          </p:cNvPr>
           <p:cNvPicPr>
             <a:picLocks noChangeAspect="1"/>
           </p:cNvPicPr>
@@ -3628,7 +3783,13 @@
       </p:sp>
       <p:sp>
         <p:nvSpPr>
-          <p:cNvPr id="3" name="Tag How"/>
+          <p:cNvPr id="3" name="Tag How" descr="">
+            <a:extLst>
+              <a:ext uri="{C183D7F6-B498-43B3-948B-1728B52AA6E4}">
+                <adec:decorative xmlns:adec="http://schemas.microsoft.com/office/drawing/2017/decorative" val="1"/>
+              </a:ext>
+            </a:extLst>
+          </p:cNvPr>
           <p:cNvSpPr/>
           <p:nvPr/>
         </p:nvSpPr>
@@ -3691,7 +3852,13 @@
       </p:sp>
       <p:sp>
         <p:nvSpPr>
-          <p:cNvPr id="5" name="Ask 1"/>
+          <p:cNvPr id="5" name="Ask 1" descr="">
+            <a:extLst>
+              <a:ext uri="{C183D7F6-B498-43B3-948B-1728B52AA6E4}">
+                <adec:decorative xmlns:adec="http://schemas.microsoft.com/office/drawing/2017/decorative" val="1"/>
+              </a:ext>
+            </a:extLst>
+          </p:cNvPr>
           <p:cNvSpPr/>
           <p:nvPr/>
         </p:nvSpPr>
@@ -3725,7 +3892,13 @@
       </p:sp>
       <p:sp>
         <p:nvSpPr>
-          <p:cNvPr id="6" name="Icon FaUserCheck"/>
+          <p:cNvPr id="6" name="Icon FaUserCheck" descr="">
+            <a:extLst>
+              <a:ext uri="{C183D7F6-B498-43B3-948B-1728B52AA6E4}">
+                <adec:decorative xmlns:adec="http://schemas.microsoft.com/office/drawing/2017/decorative" val="1"/>
+              </a:ext>
+            </a:extLst>
+          </p:cNvPr>
           <p:cNvSpPr/>
           <p:nvPr/>
         </p:nvSpPr>
@@ -3750,7 +3923,13 @@
       </p:sp>
       <p:pic>
         <p:nvPicPr>
-          <p:cNvPr id="7" name="Image 0" descr="C:\Users\whale\git\mwb-b02\presentations\_build\icons\FaUserCheck.png">    </p:cNvPr>
+          <p:cNvPr id="7" name="Image 0" descr="">
+            <a:extLst>
+              <a:ext uri="{C183D7F6-B498-43B3-948B-1728B52AA6E4}">
+                <adec:decorative xmlns:adec="http://schemas.microsoft.com/office/drawing/2017/decorative" val="1"/>
+              </a:ext>
+            </a:extLst>
+          </p:cNvPr>
           <p:cNvPicPr>
             <a:picLocks noChangeAspect="1"/>
           </p:cNvPicPr>
@@ -3827,7 +4006,13 @@
       </p:sp>
       <p:sp>
         <p:nvSpPr>
-          <p:cNvPr id="9" name="Ask 2"/>
+          <p:cNvPr id="9" name="Ask 2" descr="">
+            <a:extLst>
+              <a:ext uri="{C183D7F6-B498-43B3-948B-1728B52AA6E4}">
+                <adec:decorative xmlns:adec="http://schemas.microsoft.com/office/drawing/2017/decorative" val="1"/>
+              </a:ext>
+            </a:extLst>
+          </p:cNvPr>
           <p:cNvSpPr/>
           <p:nvPr/>
         </p:nvSpPr>
@@ -3861,7 +4046,13 @@
       </p:sp>
       <p:sp>
         <p:nvSpPr>
-          <p:cNvPr id="10" name="Icon FaListCheck"/>
+          <p:cNvPr id="10" name="Icon FaListCheck" descr="">
+            <a:extLst>
+              <a:ext uri="{C183D7F6-B498-43B3-948B-1728B52AA6E4}">
+                <adec:decorative xmlns:adec="http://schemas.microsoft.com/office/drawing/2017/decorative" val="1"/>
+              </a:ext>
+            </a:extLst>
+          </p:cNvPr>
           <p:cNvSpPr/>
           <p:nvPr/>
         </p:nvSpPr>
@@ -3886,7 +4077,13 @@
       </p:sp>
       <p:pic>
         <p:nvPicPr>
-          <p:cNvPr id="11" name="Image 1" descr="C:\Users\whale\git\mwb-b02\presentations\_build\icons\FaListCheck.png">    </p:cNvPr>
+          <p:cNvPr id="11" name="Image 1" descr="">
+            <a:extLst>
+              <a:ext uri="{C183D7F6-B498-43B3-948B-1728B52AA6E4}">
+                <adec:decorative xmlns:adec="http://schemas.microsoft.com/office/drawing/2017/decorative" val="1"/>
+              </a:ext>
+            </a:extLst>
+          </p:cNvPr>
           <p:cNvPicPr>
             <a:picLocks noChangeAspect="1"/>
           </p:cNvPicPr>
@@ -3963,7 +4160,13 @@
       </p:sp>
       <p:sp>
         <p:nvSpPr>
-          <p:cNvPr id="13" name="Ask 3"/>
+          <p:cNvPr id="13" name="Ask 3" descr="">
+            <a:extLst>
+              <a:ext uri="{C183D7F6-B498-43B3-948B-1728B52AA6E4}">
+                <adec:decorative xmlns:adec="http://schemas.microsoft.com/office/drawing/2017/decorative" val="1"/>
+              </a:ext>
+            </a:extLst>
+          </p:cNvPr>
           <p:cNvSpPr/>
           <p:nvPr/>
         </p:nvSpPr>
@@ -3997,7 +4200,13 @@
       </p:sp>
       <p:sp>
         <p:nvSpPr>
-          <p:cNvPr id="14" name="Icon FaUserClock"/>
+          <p:cNvPr id="14" name="Icon FaUserClock" descr="">
+            <a:extLst>
+              <a:ext uri="{C183D7F6-B498-43B3-948B-1728B52AA6E4}">
+                <adec:decorative xmlns:adec="http://schemas.microsoft.com/office/drawing/2017/decorative" val="1"/>
+              </a:ext>
+            </a:extLst>
+          </p:cNvPr>
           <p:cNvSpPr/>
           <p:nvPr/>
         </p:nvSpPr>
@@ -4022,7 +4231,13 @@
       </p:sp>
       <p:pic>
         <p:nvPicPr>
-          <p:cNvPr id="15" name="Image 2" descr="C:\Users\whale\git\mwb-b02\presentations\_build\icons\FaUserClock.png">    </p:cNvPr>
+          <p:cNvPr id="15" name="Image 2" descr="">
+            <a:extLst>
+              <a:ext uri="{C183D7F6-B498-43B3-948B-1728B52AA6E4}">
+                <adec:decorative xmlns:adec="http://schemas.microsoft.com/office/drawing/2017/decorative" val="1"/>
+              </a:ext>
+            </a:extLst>
+          </p:cNvPr>
           <p:cNvPicPr>
             <a:picLocks noChangeAspect="1"/>
           </p:cNvPicPr>
@@ -4099,7 +4314,13 @@
       </p:sp>
       <p:sp>
         <p:nvSpPr>
-          <p:cNvPr id="17" name="Ask 4"/>
+          <p:cNvPr id="17" name="Ask 4" descr="">
+            <a:extLst>
+              <a:ext uri="{C183D7F6-B498-43B3-948B-1728B52AA6E4}">
+                <adec:decorative xmlns:adec="http://schemas.microsoft.com/office/drawing/2017/decorative" val="1"/>
+              </a:ext>
+            </a:extLst>
+          </p:cNvPr>
           <p:cNvSpPr/>
           <p:nvPr/>
         </p:nvSpPr>
@@ -4133,7 +4354,13 @@
       </p:sp>
       <p:sp>
         <p:nvSpPr>
-          <p:cNvPr id="18" name="Icon FaFileShield"/>
+          <p:cNvPr id="18" name="Icon FaFileShield" descr="">
+            <a:extLst>
+              <a:ext uri="{C183D7F6-B498-43B3-948B-1728B52AA6E4}">
+                <adec:decorative xmlns:adec="http://schemas.microsoft.com/office/drawing/2017/decorative" val="1"/>
+              </a:ext>
+            </a:extLst>
+          </p:cNvPr>
           <p:cNvSpPr/>
           <p:nvPr/>
         </p:nvSpPr>
@@ -4158,7 +4385,13 @@
       </p:sp>
       <p:pic>
         <p:nvPicPr>
-          <p:cNvPr id="19" name="Image 3" descr="C:\Users\whale\git\mwb-b02\presentations\_build\icons\FaFileShield.png">    </p:cNvPr>
+          <p:cNvPr id="19" name="Image 3" descr="">
+            <a:extLst>
+              <a:ext uri="{C183D7F6-B498-43B3-948B-1728B52AA6E4}">
+                <adec:decorative xmlns:adec="http://schemas.microsoft.com/office/drawing/2017/decorative" val="1"/>
+              </a:ext>
+            </a:extLst>
+          </p:cNvPr>
           <p:cNvPicPr>
             <a:picLocks noChangeAspect="1"/>
           </p:cNvPicPr>
@@ -4235,7 +4468,13 @@
       </p:sp>
       <p:sp>
         <p:nvSpPr>
-          <p:cNvPr id="21" name="Close"/>
+          <p:cNvPr id="21" name="Close" descr="">
+            <a:extLst>
+              <a:ext uri="{C183D7F6-B498-43B3-948B-1728B52AA6E4}">
+                <adec:decorative xmlns:adec="http://schemas.microsoft.com/office/drawing/2017/decorative" val="1"/>
+              </a:ext>
+            </a:extLst>
+          </p:cNvPr>
           <p:cNvSpPr/>
           <p:nvPr/>
         </p:nvSpPr>
@@ -4269,7 +4508,13 @@
       </p:sp>
       <p:sp>
         <p:nvSpPr>
-          <p:cNvPr id="22" name="Icon FaBook"/>
+          <p:cNvPr id="22" name="Icon FaBook" descr="">
+            <a:extLst>
+              <a:ext uri="{C183D7F6-B498-43B3-948B-1728B52AA6E4}">
+                <adec:decorative xmlns:adec="http://schemas.microsoft.com/office/drawing/2017/decorative" val="1"/>
+              </a:ext>
+            </a:extLst>
+          </p:cNvPr>
           <p:cNvSpPr/>
           <p:nvPr/>
         </p:nvSpPr>
@@ -4294,7 +4539,13 @@
       </p:sp>
       <p:pic>
         <p:nvPicPr>
-          <p:cNvPr id="23" name="Image 4" descr="C:\Users\whale\git\mwb-b02\presentations\_build\icons\FaBook.png">    </p:cNvPr>
+          <p:cNvPr id="23" name="Image 4" descr="">
+            <a:extLst>
+              <a:ext uri="{C183D7F6-B498-43B3-948B-1728B52AA6E4}">
+                <adec:decorative xmlns:adec="http://schemas.microsoft.com/office/drawing/2017/decorative" val="1"/>
+              </a:ext>
+            </a:extLst>
+          </p:cNvPr>
           <p:cNvPicPr>
             <a:picLocks noChangeAspect="1"/>
           </p:cNvPicPr>
@@ -4936,7 +5187,13 @@
       </p:sp>
       <p:sp>
         <p:nvSpPr>
-          <p:cNvPr id="3" name="Tag Why"/>
+          <p:cNvPr id="3" name="Tag Why" descr="">
+            <a:extLst>
+              <a:ext uri="{C183D7F6-B498-43B3-948B-1728B52AA6E4}">
+                <adec:decorative xmlns:adec="http://schemas.microsoft.com/office/drawing/2017/decorative" val="1"/>
+              </a:ext>
+            </a:extLst>
+          </p:cNvPr>
           <p:cNvSpPr/>
           <p:nvPr/>
         </p:nvSpPr>
@@ -5035,7 +5292,13 @@
       </p:sp>
       <p:sp>
         <p:nvSpPr>
-          <p:cNvPr id="6" name="Icon FaLandmark"/>
+          <p:cNvPr id="6" name="Icon FaLandmark" descr="">
+            <a:extLst>
+              <a:ext uri="{C183D7F6-B498-43B3-948B-1728B52AA6E4}">
+                <adec:decorative xmlns:adec="http://schemas.microsoft.com/office/drawing/2017/decorative" val="1"/>
+              </a:ext>
+            </a:extLst>
+          </p:cNvPr>
           <p:cNvSpPr/>
           <p:nvPr/>
         </p:nvSpPr>
@@ -5060,7 +5323,13 @@
       </p:sp>
       <p:pic>
         <p:nvPicPr>
-          <p:cNvPr id="7" name="Image 0" descr="C:\Users\whale\git\mwb-b02\presentations\_build\icons\FaLandmark.png">    </p:cNvPr>
+          <p:cNvPr id="7" name="Image 0" descr="">
+            <a:extLst>
+              <a:ext uri="{C183D7F6-B498-43B3-948B-1728B52AA6E4}">
+                <adec:decorative xmlns:adec="http://schemas.microsoft.com/office/drawing/2017/decorative" val="1"/>
+              </a:ext>
+            </a:extLst>
+          </p:cNvPr>
           <p:cNvPicPr>
             <a:picLocks noChangeAspect="1"/>
           </p:cNvPicPr>
@@ -5134,7 +5403,13 @@
       </p:sp>
       <p:sp>
         <p:nvSpPr>
-          <p:cNvPr id="9" name="Icon FaBook"/>
+          <p:cNvPr id="9" name="Icon FaBook" descr="">
+            <a:extLst>
+              <a:ext uri="{C183D7F6-B498-43B3-948B-1728B52AA6E4}">
+                <adec:decorative xmlns:adec="http://schemas.microsoft.com/office/drawing/2017/decorative" val="1"/>
+              </a:ext>
+            </a:extLst>
+          </p:cNvPr>
           <p:cNvSpPr/>
           <p:nvPr/>
         </p:nvSpPr>
@@ -5159,7 +5434,13 @@
       </p:sp>
       <p:pic>
         <p:nvPicPr>
-          <p:cNvPr id="10" name="Image 1" descr="C:\Users\whale\git\mwb-b02\presentations\_build\icons\FaBook.png">    </p:cNvPr>
+          <p:cNvPr id="10" name="Image 1" descr="">
+            <a:extLst>
+              <a:ext uri="{C183D7F6-B498-43B3-948B-1728B52AA6E4}">
+                <adec:decorative xmlns:adec="http://schemas.microsoft.com/office/drawing/2017/decorative" val="1"/>
+              </a:ext>
+            </a:extLst>
+          </p:cNvPr>
           <p:cNvPicPr>
             <a:picLocks noChangeAspect="1"/>
           </p:cNvPicPr>
@@ -5233,7 +5514,13 @@
       </p:sp>
       <p:sp>
         <p:nvSpPr>
-          <p:cNvPr id="12" name="Icon FaSitemap"/>
+          <p:cNvPr id="12" name="Icon FaSitemap" descr="">
+            <a:extLst>
+              <a:ext uri="{C183D7F6-B498-43B3-948B-1728B52AA6E4}">
+                <adec:decorative xmlns:adec="http://schemas.microsoft.com/office/drawing/2017/decorative" val="1"/>
+              </a:ext>
+            </a:extLst>
+          </p:cNvPr>
           <p:cNvSpPr/>
           <p:nvPr/>
         </p:nvSpPr>
@@ -5258,7 +5545,13 @@
       </p:sp>
       <p:pic>
         <p:nvPicPr>
-          <p:cNvPr id="13" name="Image 2" descr="C:\Users\whale\git\mwb-b02\presentations\_build\icons\FaSitemap.png">    </p:cNvPr>
+          <p:cNvPr id="13" name="Image 2" descr="">
+            <a:extLst>
+              <a:ext uri="{C183D7F6-B498-43B3-948B-1728B52AA6E4}">
+                <adec:decorative xmlns:adec="http://schemas.microsoft.com/office/drawing/2017/decorative" val="1"/>
+              </a:ext>
+            </a:extLst>
+          </p:cNvPr>
           <p:cNvPicPr>
             <a:picLocks noChangeAspect="1"/>
           </p:cNvPicPr>
@@ -5332,7 +5625,13 @@
       </p:sp>
       <p:sp>
         <p:nvSpPr>
-          <p:cNvPr id="15" name="Consequence box"/>
+          <p:cNvPr id="15" name="Consequence box" descr="">
+            <a:extLst>
+              <a:ext uri="{C183D7F6-B498-43B3-948B-1728B52AA6E4}">
+                <adec:decorative xmlns:adec="http://schemas.microsoft.com/office/drawing/2017/decorative" val="1"/>
+              </a:ext>
+            </a:extLst>
+          </p:cNvPr>
           <p:cNvSpPr/>
           <p:nvPr/>
         </p:nvSpPr>
@@ -5366,7 +5665,13 @@
       </p:sp>
       <p:sp>
         <p:nvSpPr>
-          <p:cNvPr id="16" name="Icon FaIdCard"/>
+          <p:cNvPr id="16" name="Icon FaIdCard" descr="">
+            <a:extLst>
+              <a:ext uri="{C183D7F6-B498-43B3-948B-1728B52AA6E4}">
+                <adec:decorative xmlns:adec="http://schemas.microsoft.com/office/drawing/2017/decorative" val="1"/>
+              </a:ext>
+            </a:extLst>
+          </p:cNvPr>
           <p:cNvSpPr/>
           <p:nvPr/>
         </p:nvSpPr>
@@ -5391,7 +5696,13 @@
       </p:sp>
       <p:pic>
         <p:nvPicPr>
-          <p:cNvPr id="17" name="Image 3" descr="C:\Users\whale\git\mwb-b02\presentations\_build\icons\FaIdCard.png">    </p:cNvPr>
+          <p:cNvPr id="17" name="Image 3" descr="">
+            <a:extLst>
+              <a:ext uri="{C183D7F6-B498-43B3-948B-1728B52AA6E4}">
+                <adec:decorative xmlns:adec="http://schemas.microsoft.com/office/drawing/2017/decorative" val="1"/>
+              </a:ext>
+            </a:extLst>
+          </p:cNvPr>
           <p:cNvPicPr>
             <a:picLocks noChangeAspect="1"/>
           </p:cNvPicPr>
@@ -5580,7 +5891,13 @@
       </p:sp>
       <p:sp>
         <p:nvSpPr>
-          <p:cNvPr id="21" name="Not an upgrade"/>
+          <p:cNvPr id="21" name="Not an upgrade" descr="">
+            <a:extLst>
+              <a:ext uri="{C183D7F6-B498-43B3-948B-1728B52AA6E4}">
+                <adec:decorative xmlns:adec="http://schemas.microsoft.com/office/drawing/2017/decorative" val="1"/>
+              </a:ext>
+            </a:extLst>
+          </p:cNvPr>
           <p:cNvSpPr/>
           <p:nvPr/>
         </p:nvSpPr>
@@ -5614,7 +5931,13 @@
       </p:sp>
       <p:sp>
         <p:nvSpPr>
-          <p:cNvPr id="22" name="Icon FaTriangleExclamation"/>
+          <p:cNvPr id="22" name="Icon FaTriangleExclamation" descr="">
+            <a:extLst>
+              <a:ext uri="{C183D7F6-B498-43B3-948B-1728B52AA6E4}">
+                <adec:decorative xmlns:adec="http://schemas.microsoft.com/office/drawing/2017/decorative" val="1"/>
+              </a:ext>
+            </a:extLst>
+          </p:cNvPr>
           <p:cNvSpPr/>
           <p:nvPr/>
         </p:nvSpPr>
@@ -5639,7 +5962,13 @@
       </p:sp>
       <p:pic>
         <p:nvPicPr>
-          <p:cNvPr id="23" name="Image 4" descr="C:\Users\whale\git\mwb-b02\presentations\_build\icons\FaTriangleExclamation.png">    </p:cNvPr>
+          <p:cNvPr id="23" name="Image 4" descr="">
+            <a:extLst>
+              <a:ext uri="{C183D7F6-B498-43B3-948B-1728B52AA6E4}">
+                <adec:decorative xmlns:adec="http://schemas.microsoft.com/office/drawing/2017/decorative" val="1"/>
+              </a:ext>
+            </a:extLst>
+          </p:cNvPr>
           <p:cNvPicPr>
             <a:picLocks noChangeAspect="1"/>
           </p:cNvPicPr>
@@ -5857,7 +6186,13 @@
       </p:sp>
       <p:sp>
         <p:nvSpPr>
-          <p:cNvPr id="3" name="Tag Why"/>
+          <p:cNvPr id="3" name="Tag Why" descr="">
+            <a:extLst>
+              <a:ext uri="{C183D7F6-B498-43B3-948B-1728B52AA6E4}">
+                <adec:decorative xmlns:adec="http://schemas.microsoft.com/office/drawing/2017/decorative" val="1"/>
+              </a:ext>
+            </a:extLst>
+          </p:cNvPr>
           <p:cNvSpPr/>
           <p:nvPr/>
         </p:nvSpPr>
@@ -5920,7 +6255,13 @@
       </p:sp>
       <p:sp>
         <p:nvSpPr>
-          <p:cNvPr id="5" name="Date 1"/>
+          <p:cNvPr id="5" name="Date 1" descr="">
+            <a:extLst>
+              <a:ext uri="{C183D7F6-B498-43B3-948B-1728B52AA6E4}">
+                <adec:decorative xmlns:adec="http://schemas.microsoft.com/office/drawing/2017/decorative" val="1"/>
+              </a:ext>
+            </a:extLst>
+          </p:cNvPr>
           <p:cNvSpPr/>
           <p:nvPr/>
         </p:nvSpPr>
@@ -6013,7 +6354,13 @@
       </p:sp>
       <p:sp>
         <p:nvSpPr>
-          <p:cNvPr id="7" name="Date 2"/>
+          <p:cNvPr id="7" name="Date 2" descr="">
+            <a:extLst>
+              <a:ext uri="{C183D7F6-B498-43B3-948B-1728B52AA6E4}">
+                <adec:decorative xmlns:adec="http://schemas.microsoft.com/office/drawing/2017/decorative" val="1"/>
+              </a:ext>
+            </a:extLst>
+          </p:cNvPr>
           <p:cNvSpPr/>
           <p:nvPr/>
         </p:nvSpPr>
@@ -6106,7 +6453,13 @@
       </p:sp>
       <p:sp>
         <p:nvSpPr>
-          <p:cNvPr id="9" name="Date 3"/>
+          <p:cNvPr id="9" name="Date 3" descr="">
+            <a:extLst>
+              <a:ext uri="{C183D7F6-B498-43B3-948B-1728B52AA6E4}">
+                <adec:decorative xmlns:adec="http://schemas.microsoft.com/office/drawing/2017/decorative" val="1"/>
+              </a:ext>
+            </a:extLst>
+          </p:cNvPr>
           <p:cNvSpPr/>
           <p:nvPr/>
         </p:nvSpPr>
@@ -6199,7 +6552,13 @@
       </p:sp>
       <p:sp>
         <p:nvSpPr>
-          <p:cNvPr id="11" name="Date 4"/>
+          <p:cNvPr id="11" name="Date 4" descr="">
+            <a:extLst>
+              <a:ext uri="{C183D7F6-B498-43B3-948B-1728B52AA6E4}">
+                <adec:decorative xmlns:adec="http://schemas.microsoft.com/office/drawing/2017/decorative" val="1"/>
+              </a:ext>
+            </a:extLst>
+          </p:cNvPr>
           <p:cNvSpPr/>
           <p:nvPr/>
         </p:nvSpPr>
@@ -6339,7 +6698,13 @@
       </p:sp>
       <p:sp>
         <p:nvSpPr>
-          <p:cNvPr id="14" name="Lift and shift"/>
+          <p:cNvPr id="14" name="Lift and shift" descr="">
+            <a:extLst>
+              <a:ext uri="{C183D7F6-B498-43B3-948B-1728B52AA6E4}">
+                <adec:decorative xmlns:adec="http://schemas.microsoft.com/office/drawing/2017/decorative" val="1"/>
+              </a:ext>
+            </a:extLst>
+          </p:cNvPr>
           <p:cNvSpPr/>
           <p:nvPr/>
         </p:nvSpPr>
@@ -6373,7 +6738,13 @@
       </p:sp>
       <p:sp>
         <p:nvSpPr>
-          <p:cNvPr id="15" name="Icon FaPlugCircleXmark"/>
+          <p:cNvPr id="15" name="Icon FaPlugCircleXmark" descr="">
+            <a:extLst>
+              <a:ext uri="{C183D7F6-B498-43B3-948B-1728B52AA6E4}">
+                <adec:decorative xmlns:adec="http://schemas.microsoft.com/office/drawing/2017/decorative" val="1"/>
+              </a:ext>
+            </a:extLst>
+          </p:cNvPr>
           <p:cNvSpPr/>
           <p:nvPr/>
         </p:nvSpPr>
@@ -6398,7 +6769,13 @@
       </p:sp>
       <p:pic>
         <p:nvPicPr>
-          <p:cNvPr id="16" name="Image 0" descr="C:\Users\whale\git\mwb-b02\presentations\_build\icons\FaPlugCircleXmark.png">    </p:cNvPr>
+          <p:cNvPr id="16" name="Image 0" descr="">
+            <a:extLst>
+              <a:ext uri="{C183D7F6-B498-43B3-948B-1728B52AA6E4}">
+                <adec:decorative xmlns:adec="http://schemas.microsoft.com/office/drawing/2017/decorative" val="1"/>
+              </a:ext>
+            </a:extLst>
+          </p:cNvPr>
           <p:cNvPicPr>
             <a:picLocks noChangeAspect="1"/>
           </p:cNvPicPr>
@@ -6616,7 +6993,13 @@
       </p:sp>
       <p:sp>
         <p:nvSpPr>
-          <p:cNvPr id="3" name="Tag What"/>
+          <p:cNvPr id="3" name="Tag What" descr="">
+            <a:extLst>
+              <a:ext uri="{C183D7F6-B498-43B3-948B-1728B52AA6E4}">
+                <adec:decorative xmlns:adec="http://schemas.microsoft.com/office/drawing/2017/decorative" val="1"/>
+              </a:ext>
+            </a:extLst>
+          </p:cNvPr>
           <p:cNvSpPr/>
           <p:nvPr/>
         </p:nvSpPr>
@@ -6698,7 +7081,7 @@
         <a:graphic>
           <a:graphicData uri="http://schemas.openxmlformats.org/drawingml/2006/table">
             <a:tbl>
-              <a:tblPr/>
+              <a:tblPr firstRow="1" bandRow="1"/>
               <a:tblGrid>
                 <a:gridCol w="1965960"/>
                 <a:gridCol w="4206240"/>
@@ -8141,7 +8524,13 @@
       </p:graphicFrame>
       <p:sp>
         <p:nvSpPr>
-          <p:cNvPr id="6" name="Key idea"/>
+          <p:cNvPr id="6" name="Key idea" descr="">
+            <a:extLst>
+              <a:ext uri="{C183D7F6-B498-43B3-948B-1728B52AA6E4}">
+                <adec:decorative xmlns:adec="http://schemas.microsoft.com/office/drawing/2017/decorative" val="1"/>
+              </a:ext>
+            </a:extLst>
+          </p:cNvPr>
           <p:cNvSpPr/>
           <p:nvPr/>
         </p:nvSpPr>
@@ -8175,7 +8564,13 @@
       </p:sp>
       <p:sp>
         <p:nvSpPr>
-          <p:cNvPr id="7" name="Icon FaRightLeft"/>
+          <p:cNvPr id="7" name="Icon FaRightLeft" descr="">
+            <a:extLst>
+              <a:ext uri="{C183D7F6-B498-43B3-948B-1728B52AA6E4}">
+                <adec:decorative xmlns:adec="http://schemas.microsoft.com/office/drawing/2017/decorative" val="1"/>
+              </a:ext>
+            </a:extLst>
+          </p:cNvPr>
           <p:cNvSpPr/>
           <p:nvPr/>
         </p:nvSpPr>
@@ -8200,7 +8595,13 @@
       </p:sp>
       <p:pic>
         <p:nvPicPr>
-          <p:cNvPr id="8" name="Image 0" descr="C:\Users\whale\git\mwb-b02\presentations\_build\icons\FaRightLeft.png">    </p:cNvPr>
+          <p:cNvPr id="8" name="Image 0" descr="">
+            <a:extLst>
+              <a:ext uri="{C183D7F6-B498-43B3-948B-1728B52AA6E4}">
+                <adec:decorative xmlns:adec="http://schemas.microsoft.com/office/drawing/2017/decorative" val="1"/>
+              </a:ext>
+            </a:extLst>
+          </p:cNvPr>
           <p:cNvPicPr>
             <a:picLocks noChangeAspect="1"/>
           </p:cNvPicPr>
@@ -8418,7 +8819,13 @@
       </p:sp>
       <p:sp>
         <p:nvSpPr>
-          <p:cNvPr id="3" name="Tag What"/>
+          <p:cNvPr id="3" name="Tag What" descr="">
+            <a:extLst>
+              <a:ext uri="{C183D7F6-B498-43B3-948B-1728B52AA6E4}">
+                <adec:decorative xmlns:adec="http://schemas.microsoft.com/office/drawing/2017/decorative" val="1"/>
+              </a:ext>
+            </a:extLst>
+          </p:cNvPr>
           <p:cNvSpPr/>
           <p:nvPr/>
         </p:nvSpPr>
@@ -8517,7 +8924,13 @@
       </p:sp>
       <p:sp>
         <p:nvSpPr>
-          <p:cNvPr id="6" name="Dep 1"/>
+          <p:cNvPr id="6" name="Dep 1" descr="">
+            <a:extLst>
+              <a:ext uri="{C183D7F6-B498-43B3-948B-1728B52AA6E4}">
+                <adec:decorative xmlns:adec="http://schemas.microsoft.com/office/drawing/2017/decorative" val="1"/>
+              </a:ext>
+            </a:extLst>
+          </p:cNvPr>
           <p:cNvSpPr/>
           <p:nvPr/>
         </p:nvSpPr>
@@ -8551,7 +8964,13 @@
       </p:sp>
       <p:sp>
         <p:nvSpPr>
-          <p:cNvPr id="7" name="Icon FaGlobe"/>
+          <p:cNvPr id="7" name="Icon FaGlobe" descr="">
+            <a:extLst>
+              <a:ext uri="{C183D7F6-B498-43B3-948B-1728B52AA6E4}">
+                <adec:decorative xmlns:adec="http://schemas.microsoft.com/office/drawing/2017/decorative" val="1"/>
+              </a:ext>
+            </a:extLst>
+          </p:cNvPr>
           <p:cNvSpPr/>
           <p:nvPr/>
         </p:nvSpPr>
@@ -8576,7 +8995,13 @@
       </p:sp>
       <p:pic>
         <p:nvPicPr>
-          <p:cNvPr id="8" name="Image 0" descr="C:\Users\whale\git\mwb-b02\presentations\_build\icons\FaGlobe.png">    </p:cNvPr>
+          <p:cNvPr id="8" name="Image 0" descr="">
+            <a:extLst>
+              <a:ext uri="{C183D7F6-B498-43B3-948B-1728B52AA6E4}">
+                <adec:decorative xmlns:adec="http://schemas.microsoft.com/office/drawing/2017/decorative" val="1"/>
+              </a:ext>
+            </a:extLst>
+          </p:cNvPr>
           <p:cNvPicPr>
             <a:picLocks noChangeAspect="1"/>
           </p:cNvPicPr>
@@ -8650,7 +9075,13 @@
       </p:sp>
       <p:sp>
         <p:nvSpPr>
-          <p:cNvPr id="10" name="Dep 2"/>
+          <p:cNvPr id="10" name="Dep 2" descr="">
+            <a:extLst>
+              <a:ext uri="{C183D7F6-B498-43B3-948B-1728B52AA6E4}">
+                <adec:decorative xmlns:adec="http://schemas.microsoft.com/office/drawing/2017/decorative" val="1"/>
+              </a:ext>
+            </a:extLst>
+          </p:cNvPr>
           <p:cNvSpPr/>
           <p:nvPr/>
         </p:nvSpPr>
@@ -8684,7 +9115,13 @@
       </p:sp>
       <p:sp>
         <p:nvSpPr>
-          <p:cNvPr id="11" name="Icon FaKey"/>
+          <p:cNvPr id="11" name="Icon FaKey" descr="">
+            <a:extLst>
+              <a:ext uri="{C183D7F6-B498-43B3-948B-1728B52AA6E4}">
+                <adec:decorative xmlns:adec="http://schemas.microsoft.com/office/drawing/2017/decorative" val="1"/>
+              </a:ext>
+            </a:extLst>
+          </p:cNvPr>
           <p:cNvSpPr/>
           <p:nvPr/>
         </p:nvSpPr>
@@ -8709,7 +9146,13 @@
       </p:sp>
       <p:pic>
         <p:nvPicPr>
-          <p:cNvPr id="12" name="Image 1" descr="C:\Users\whale\git\mwb-b02\presentations\_build\icons\FaKey.png">    </p:cNvPr>
+          <p:cNvPr id="12" name="Image 1" descr="">
+            <a:extLst>
+              <a:ext uri="{C183D7F6-B498-43B3-948B-1728B52AA6E4}">
+                <adec:decorative xmlns:adec="http://schemas.microsoft.com/office/drawing/2017/decorative" val="1"/>
+              </a:ext>
+            </a:extLst>
+          </p:cNvPr>
           <p:cNvPicPr>
             <a:picLocks noChangeAspect="1"/>
           </p:cNvPicPr>
@@ -8783,7 +9226,13 @@
       </p:sp>
       <p:sp>
         <p:nvSpPr>
-          <p:cNvPr id="14" name="Dep 3"/>
+          <p:cNvPr id="14" name="Dep 3" descr="">
+            <a:extLst>
+              <a:ext uri="{C183D7F6-B498-43B3-948B-1728B52AA6E4}">
+                <adec:decorative xmlns:adec="http://schemas.microsoft.com/office/drawing/2017/decorative" val="1"/>
+              </a:ext>
+            </a:extLst>
+          </p:cNvPr>
           <p:cNvSpPr/>
           <p:nvPr/>
         </p:nvSpPr>
@@ -8817,7 +9266,13 @@
       </p:sp>
       <p:sp>
         <p:nvSpPr>
-          <p:cNvPr id="15" name="Icon FaRoute"/>
+          <p:cNvPr id="15" name="Icon FaRoute" descr="">
+            <a:extLst>
+              <a:ext uri="{C183D7F6-B498-43B3-948B-1728B52AA6E4}">
+                <adec:decorative xmlns:adec="http://schemas.microsoft.com/office/drawing/2017/decorative" val="1"/>
+              </a:ext>
+            </a:extLst>
+          </p:cNvPr>
           <p:cNvSpPr/>
           <p:nvPr/>
         </p:nvSpPr>
@@ -8842,7 +9297,13 @@
       </p:sp>
       <p:pic>
         <p:nvPicPr>
-          <p:cNvPr id="16" name="Image 2" descr="C:\Users\whale\git\mwb-b02\presentations\_build\icons\FaRoute.png">    </p:cNvPr>
+          <p:cNvPr id="16" name="Image 2" descr="">
+            <a:extLst>
+              <a:ext uri="{C183D7F6-B498-43B3-948B-1728B52AA6E4}">
+                <adec:decorative xmlns:adec="http://schemas.microsoft.com/office/drawing/2017/decorative" val="1"/>
+              </a:ext>
+            </a:extLst>
+          </p:cNvPr>
           <p:cNvPicPr>
             <a:picLocks noChangeAspect="1"/>
           </p:cNvPicPr>
@@ -8916,7 +9377,13 @@
       </p:sp>
       <p:sp>
         <p:nvSpPr>
-          <p:cNvPr id="18" name="Dep 4"/>
+          <p:cNvPr id="18" name="Dep 4" descr="">
+            <a:extLst>
+              <a:ext uri="{C183D7F6-B498-43B3-948B-1728B52AA6E4}">
+                <adec:decorative xmlns:adec="http://schemas.microsoft.com/office/drawing/2017/decorative" val="1"/>
+              </a:ext>
+            </a:extLst>
+          </p:cNvPr>
           <p:cNvSpPr/>
           <p:nvPr/>
         </p:nvSpPr>
@@ -8950,7 +9417,13 @@
       </p:sp>
       <p:sp>
         <p:nvSpPr>
-          <p:cNvPr id="19" name="Icon FaPlugCircleXmark"/>
+          <p:cNvPr id="19" name="Icon FaPlugCircleXmark" descr="">
+            <a:extLst>
+              <a:ext uri="{C183D7F6-B498-43B3-948B-1728B52AA6E4}">
+                <adec:decorative xmlns:adec="http://schemas.microsoft.com/office/drawing/2017/decorative" val="1"/>
+              </a:ext>
+            </a:extLst>
+          </p:cNvPr>
           <p:cNvSpPr/>
           <p:nvPr/>
         </p:nvSpPr>
@@ -8975,7 +9448,13 @@
       </p:sp>
       <p:pic>
         <p:nvPicPr>
-          <p:cNvPr id="20" name="Image 3" descr="C:\Users\whale\git\mwb-b02\presentations\_build\icons\FaPlugCircleXmark.png">    </p:cNvPr>
+          <p:cNvPr id="20" name="Image 3" descr="">
+            <a:extLst>
+              <a:ext uri="{C183D7F6-B498-43B3-948B-1728B52AA6E4}">
+                <adec:decorative xmlns:adec="http://schemas.microsoft.com/office/drawing/2017/decorative" val="1"/>
+              </a:ext>
+            </a:extLst>
+          </p:cNvPr>
           <p:cNvPicPr>
             <a:picLocks noChangeAspect="1"/>
           </p:cNvPicPr>
@@ -9049,7 +9528,13 @@
       </p:sp>
       <p:sp>
         <p:nvSpPr>
-          <p:cNvPr id="22" name="Dep 5"/>
+          <p:cNvPr id="22" name="Dep 5" descr="">
+            <a:extLst>
+              <a:ext uri="{C183D7F6-B498-43B3-948B-1728B52AA6E4}">
+                <adec:decorative xmlns:adec="http://schemas.microsoft.com/office/drawing/2017/decorative" val="1"/>
+              </a:ext>
+            </a:extLst>
+          </p:cNvPr>
           <p:cNvSpPr/>
           <p:nvPr/>
         </p:nvSpPr>
@@ -9083,7 +9568,13 @@
       </p:sp>
       <p:sp>
         <p:nvSpPr>
-          <p:cNvPr id="23" name="Icon FaArrowsRotate"/>
+          <p:cNvPr id="23" name="Icon FaArrowsRotate" descr="">
+            <a:extLst>
+              <a:ext uri="{C183D7F6-B498-43B3-948B-1728B52AA6E4}">
+                <adec:decorative xmlns:adec="http://schemas.microsoft.com/office/drawing/2017/decorative" val="1"/>
+              </a:ext>
+            </a:extLst>
+          </p:cNvPr>
           <p:cNvSpPr/>
           <p:nvPr/>
         </p:nvSpPr>
@@ -9108,7 +9599,13 @@
       </p:sp>
       <p:pic>
         <p:nvPicPr>
-          <p:cNvPr id="24" name="Image 4" descr="C:\Users\whale\git\mwb-b02\presentations\_build\icons\FaArrowsRotate.png">    </p:cNvPr>
+          <p:cNvPr id="24" name="Image 4" descr="">
+            <a:extLst>
+              <a:ext uri="{C183D7F6-B498-43B3-948B-1728B52AA6E4}">
+                <adec:decorative xmlns:adec="http://schemas.microsoft.com/office/drawing/2017/decorative" val="1"/>
+              </a:ext>
+            </a:extLst>
+          </p:cNvPr>
           <p:cNvPicPr>
             <a:picLocks noChangeAspect="1"/>
           </p:cNvPicPr>
@@ -9182,7 +9679,13 @@
       </p:sp>
       <p:sp>
         <p:nvSpPr>
-          <p:cNvPr id="26" name="Dep 6"/>
+          <p:cNvPr id="26" name="Dep 6" descr="">
+            <a:extLst>
+              <a:ext uri="{C183D7F6-B498-43B3-948B-1728B52AA6E4}">
+                <adec:decorative xmlns:adec="http://schemas.microsoft.com/office/drawing/2017/decorative" val="1"/>
+              </a:ext>
+            </a:extLst>
+          </p:cNvPr>
           <p:cNvSpPr/>
           <p:nvPr/>
         </p:nvSpPr>
@@ -9216,7 +9719,13 @@
       </p:sp>
       <p:sp>
         <p:nvSpPr>
-          <p:cNvPr id="27" name="Icon FaLaptop"/>
+          <p:cNvPr id="27" name="Icon FaLaptop" descr="">
+            <a:extLst>
+              <a:ext uri="{C183D7F6-B498-43B3-948B-1728B52AA6E4}">
+                <adec:decorative xmlns:adec="http://schemas.microsoft.com/office/drawing/2017/decorative" val="1"/>
+              </a:ext>
+            </a:extLst>
+          </p:cNvPr>
           <p:cNvSpPr/>
           <p:nvPr/>
         </p:nvSpPr>
@@ -9241,7 +9750,13 @@
       </p:sp>
       <p:pic>
         <p:nvPicPr>
-          <p:cNvPr id="28" name="Image 5" descr="C:\Users\whale\git\mwb-b02\presentations\_build\icons\FaLaptop.png">    </p:cNvPr>
+          <p:cNvPr id="28" name="Image 5" descr="">
+            <a:extLst>
+              <a:ext uri="{C183D7F6-B498-43B3-948B-1728B52AA6E4}">
+                <adec:decorative xmlns:adec="http://schemas.microsoft.com/office/drawing/2017/decorative" val="1"/>
+              </a:ext>
+            </a:extLst>
+          </p:cNvPr>
           <p:cNvPicPr>
             <a:picLocks noChangeAspect="1"/>
           </p:cNvPicPr>
@@ -9315,7 +9830,13 @@
       </p:sp>
       <p:sp>
         <p:nvSpPr>
-          <p:cNvPr id="30" name="Dep 7"/>
+          <p:cNvPr id="30" name="Dep 7" descr="">
+            <a:extLst>
+              <a:ext uri="{C183D7F6-B498-43B3-948B-1728B52AA6E4}">
+                <adec:decorative xmlns:adec="http://schemas.microsoft.com/office/drawing/2017/decorative" val="1"/>
+              </a:ext>
+            </a:extLst>
+          </p:cNvPr>
           <p:cNvSpPr/>
           <p:nvPr/>
         </p:nvSpPr>
@@ -9349,7 +9870,13 @@
       </p:sp>
       <p:sp>
         <p:nvSpPr>
-          <p:cNvPr id="31" name="Icon FaUserClock"/>
+          <p:cNvPr id="31" name="Icon FaUserClock" descr="">
+            <a:extLst>
+              <a:ext uri="{C183D7F6-B498-43B3-948B-1728B52AA6E4}">
+                <adec:decorative xmlns:adec="http://schemas.microsoft.com/office/drawing/2017/decorative" val="1"/>
+              </a:ext>
+            </a:extLst>
+          </p:cNvPr>
           <p:cNvSpPr/>
           <p:nvPr/>
         </p:nvSpPr>
@@ -9374,7 +9901,13 @@
       </p:sp>
       <p:pic>
         <p:nvPicPr>
-          <p:cNvPr id="32" name="Image 6" descr="C:\Users\whale\git\mwb-b02\presentations\_build\icons\FaUserClock.png">    </p:cNvPr>
+          <p:cNvPr id="32" name="Image 6" descr="">
+            <a:extLst>
+              <a:ext uri="{C183D7F6-B498-43B3-948B-1728B52AA6E4}">
+                <adec:decorative xmlns:adec="http://schemas.microsoft.com/office/drawing/2017/decorative" val="1"/>
+              </a:ext>
+            </a:extLst>
+          </p:cNvPr>
           <p:cNvPicPr>
             <a:picLocks noChangeAspect="1"/>
           </p:cNvPicPr>
@@ -9448,7 +9981,13 @@
       </p:sp>
       <p:sp>
         <p:nvSpPr>
-          <p:cNvPr id="34" name="Dep 8"/>
+          <p:cNvPr id="34" name="Dep 8" descr="">
+            <a:extLst>
+              <a:ext uri="{C183D7F6-B498-43B3-948B-1728B52AA6E4}">
+                <adec:decorative xmlns:adec="http://schemas.microsoft.com/office/drawing/2017/decorative" val="1"/>
+              </a:ext>
+            </a:extLst>
+          </p:cNvPr>
           <p:cNvSpPr/>
           <p:nvPr/>
         </p:nvSpPr>
@@ -9482,7 +10021,13 @@
       </p:sp>
       <p:sp>
         <p:nvSpPr>
-          <p:cNvPr id="35" name="Icon FaDatabase"/>
+          <p:cNvPr id="35" name="Icon FaDatabase" descr="">
+            <a:extLst>
+              <a:ext uri="{C183D7F6-B498-43B3-948B-1728B52AA6E4}">
+                <adec:decorative xmlns:adec="http://schemas.microsoft.com/office/drawing/2017/decorative" val="1"/>
+              </a:ext>
+            </a:extLst>
+          </p:cNvPr>
           <p:cNvSpPr/>
           <p:nvPr/>
         </p:nvSpPr>
@@ -9507,7 +10052,13 @@
       </p:sp>
       <p:pic>
         <p:nvPicPr>
-          <p:cNvPr id="36" name="Image 7" descr="C:\Users\whale\git\mwb-b02\presentations\_build\icons\FaDatabase.png">    </p:cNvPr>
+          <p:cNvPr id="36" name="Image 7" descr="">
+            <a:extLst>
+              <a:ext uri="{C183D7F6-B498-43B3-948B-1728B52AA6E4}">
+                <adec:decorative xmlns:adec="http://schemas.microsoft.com/office/drawing/2017/decorative" val="1"/>
+              </a:ext>
+            </a:extLst>
+          </p:cNvPr>
           <p:cNvPicPr>
             <a:picLocks noChangeAspect="1"/>
           </p:cNvPicPr>
@@ -9581,7 +10132,13 @@
       </p:sp>
       <p:sp>
         <p:nvSpPr>
-          <p:cNvPr id="38" name="Adapters"/>
+          <p:cNvPr id="38" name="Adapters" descr="">
+            <a:extLst>
+              <a:ext uri="{C183D7F6-B498-43B3-948B-1728B52AA6E4}">
+                <adec:decorative xmlns:adec="http://schemas.microsoft.com/office/drawing/2017/decorative" val="1"/>
+              </a:ext>
+            </a:extLst>
+          </p:cNvPr>
           <p:cNvSpPr/>
           <p:nvPr/>
         </p:nvSpPr>
@@ -9615,7 +10172,13 @@
       </p:sp>
       <p:sp>
         <p:nvSpPr>
-          <p:cNvPr id="39" name="Icon FaCubes"/>
+          <p:cNvPr id="39" name="Icon FaCubes" descr="">
+            <a:extLst>
+              <a:ext uri="{C183D7F6-B498-43B3-948B-1728B52AA6E4}">
+                <adec:decorative xmlns:adec="http://schemas.microsoft.com/office/drawing/2017/decorative" val="1"/>
+              </a:ext>
+            </a:extLst>
+          </p:cNvPr>
           <p:cNvSpPr/>
           <p:nvPr/>
         </p:nvSpPr>
@@ -9640,7 +10203,13 @@
       </p:sp>
       <p:pic>
         <p:nvPicPr>
-          <p:cNvPr id="40" name="Image 8" descr="C:\Users\whale\git\mwb-b02\presentations\_build\icons\FaCubes.png">    </p:cNvPr>
+          <p:cNvPr id="40" name="Image 8" descr="">
+            <a:extLst>
+              <a:ext uri="{C183D7F6-B498-43B3-948B-1728B52AA6E4}">
+                <adec:decorative xmlns:adec="http://schemas.microsoft.com/office/drawing/2017/decorative" val="1"/>
+              </a:ext>
+            </a:extLst>
+          </p:cNvPr>
           <p:cNvPicPr>
             <a:picLocks noChangeAspect="1"/>
           </p:cNvPicPr>
@@ -9858,7 +10427,13 @@
       </p:sp>
       <p:sp>
         <p:nvSpPr>
-          <p:cNvPr id="3" name="Tag What"/>
+          <p:cNvPr id="3" name="Tag What" descr="">
+            <a:extLst>
+              <a:ext uri="{C183D7F6-B498-43B3-948B-1728B52AA6E4}">
+                <adec:decorative xmlns:adec="http://schemas.microsoft.com/office/drawing/2017/decorative" val="1"/>
+              </a:ext>
+            </a:extLst>
+          </p:cNvPr>
           <p:cNvSpPr/>
           <p:nvPr/>
         </p:nvSpPr>
@@ -9921,7 +10496,13 @@
       </p:sp>
       <p:sp>
         <p:nvSpPr>
-          <p:cNvPr id="5" name="Tier 0"/>
+          <p:cNvPr id="5" name="Tier 0" descr="">
+            <a:extLst>
+              <a:ext uri="{C183D7F6-B498-43B3-948B-1728B52AA6E4}">
+                <adec:decorative xmlns:adec="http://schemas.microsoft.com/office/drawing/2017/decorative" val="1"/>
+              </a:ext>
+            </a:extLst>
+          </p:cNvPr>
           <p:cNvSpPr/>
           <p:nvPr/>
         </p:nvSpPr>
@@ -10005,7 +10586,13 @@
       </p:sp>
       <p:sp>
         <p:nvSpPr>
-          <p:cNvPr id="7" name="Tier 1"/>
+          <p:cNvPr id="7" name="Tier 1" descr="">
+            <a:extLst>
+              <a:ext uri="{C183D7F6-B498-43B3-948B-1728B52AA6E4}">
+                <adec:decorative xmlns:adec="http://schemas.microsoft.com/office/drawing/2017/decorative" val="1"/>
+              </a:ext>
+            </a:extLst>
+          </p:cNvPr>
           <p:cNvSpPr/>
           <p:nvPr/>
         </p:nvSpPr>
@@ -10089,7 +10676,13 @@
       </p:sp>
       <p:sp>
         <p:nvSpPr>
-          <p:cNvPr id="9" name="Tier 2"/>
+          <p:cNvPr id="9" name="Tier 2" descr="">
+            <a:extLst>
+              <a:ext uri="{C183D7F6-B498-43B3-948B-1728B52AA6E4}">
+                <adec:decorative xmlns:adec="http://schemas.microsoft.com/office/drawing/2017/decorative" val="1"/>
+              </a:ext>
+            </a:extLst>
+          </p:cNvPr>
           <p:cNvSpPr/>
           <p:nvPr/>
         </p:nvSpPr>
@@ -10173,7 +10766,13 @@
       </p:sp>
       <p:sp>
         <p:nvSpPr>
-          <p:cNvPr id="11" name="Facts box"/>
+          <p:cNvPr id="11" name="Facts box" descr="">
+            <a:extLst>
+              <a:ext uri="{C183D7F6-B498-43B3-948B-1728B52AA6E4}">
+                <adec:decorative xmlns:adec="http://schemas.microsoft.com/office/drawing/2017/decorative" val="1"/>
+              </a:ext>
+            </a:extLst>
+          </p:cNvPr>
           <p:cNvSpPr/>
           <p:nvPr/>
         </p:nvSpPr>
@@ -10337,7 +10936,13 @@
       </p:sp>
       <p:sp>
         <p:nvSpPr>
-          <p:cNvPr id="14" name="Decision"/>
+          <p:cNvPr id="14" name="Decision" descr="">
+            <a:extLst>
+              <a:ext uri="{C183D7F6-B498-43B3-948B-1728B52AA6E4}">
+                <adec:decorative xmlns:adec="http://schemas.microsoft.com/office/drawing/2017/decorative" val="1"/>
+              </a:ext>
+            </a:extLst>
+          </p:cNvPr>
           <p:cNvSpPr/>
           <p:nvPr/>
         </p:nvSpPr>
@@ -10371,7 +10976,13 @@
       </p:sp>
       <p:sp>
         <p:nvSpPr>
-          <p:cNvPr id="15" name="Icon FaScaleBalanced"/>
+          <p:cNvPr id="15" name="Icon FaScaleBalanced" descr="">
+            <a:extLst>
+              <a:ext uri="{C183D7F6-B498-43B3-948B-1728B52AA6E4}">
+                <adec:decorative xmlns:adec="http://schemas.microsoft.com/office/drawing/2017/decorative" val="1"/>
+              </a:ext>
+            </a:extLst>
+          </p:cNvPr>
           <p:cNvSpPr/>
           <p:nvPr/>
         </p:nvSpPr>
@@ -10396,7 +11007,13 @@
       </p:sp>
       <p:pic>
         <p:nvPicPr>
-          <p:cNvPr id="16" name="Image 0" descr="C:\Users\whale\git\mwb-b02\presentations\_build\icons\FaScaleBalanced.png">    </p:cNvPr>
+          <p:cNvPr id="16" name="Image 0" descr="">
+            <a:extLst>
+              <a:ext uri="{C183D7F6-B498-43B3-948B-1728B52AA6E4}">
+                <adec:decorative xmlns:adec="http://schemas.microsoft.com/office/drawing/2017/decorative" val="1"/>
+              </a:ext>
+            </a:extLst>
+          </p:cNvPr>
           <p:cNvPicPr>
             <a:picLocks noChangeAspect="1"/>
           </p:cNvPicPr>
@@ -10614,7 +11231,13 @@
       </p:sp>
       <p:sp>
         <p:nvSpPr>
-          <p:cNvPr id="3" name="Tag What"/>
+          <p:cNvPr id="3" name="Tag What" descr="">
+            <a:extLst>
+              <a:ext uri="{C183D7F6-B498-43B3-948B-1728B52AA6E4}">
+                <adec:decorative xmlns:adec="http://schemas.microsoft.com/office/drawing/2017/decorative" val="1"/>
+              </a:ext>
+            </a:extLst>
+          </p:cNvPr>
           <p:cNvSpPr/>
           <p:nvPr/>
         </p:nvSpPr>
@@ -10696,7 +11319,7 @@
         <a:graphic>
           <a:graphicData uri="http://schemas.openxmlformats.org/drawingml/2006/table">
             <a:tbl>
-              <a:tblPr/>
+              <a:tblPr firstRow="1" bandRow="1"/>
               <a:tblGrid>
                 <a:gridCol w="777240"/>
                 <a:gridCol w="2377440"/>
@@ -11738,7 +12361,13 @@
       </p:graphicFrame>
       <p:sp>
         <p:nvSpPr>
-          <p:cNvPr id="6" name="Off box"/>
+          <p:cNvPr id="6" name="Off box" descr="">
+            <a:extLst>
+              <a:ext uri="{C183D7F6-B498-43B3-948B-1728B52AA6E4}">
+                <adec:decorative xmlns:adec="http://schemas.microsoft.com/office/drawing/2017/decorative" val="1"/>
+              </a:ext>
+            </a:extLst>
+          </p:cNvPr>
           <p:cNvSpPr/>
           <p:nvPr/>
         </p:nvSpPr>
@@ -11772,7 +12401,13 @@
       </p:sp>
       <p:sp>
         <p:nvSpPr>
-          <p:cNvPr id="7" name="Icon FaLock"/>
+          <p:cNvPr id="7" name="Icon FaLock" descr="">
+            <a:extLst>
+              <a:ext uri="{C183D7F6-B498-43B3-948B-1728B52AA6E4}">
+                <adec:decorative xmlns:adec="http://schemas.microsoft.com/office/drawing/2017/decorative" val="1"/>
+              </a:ext>
+            </a:extLst>
+          </p:cNvPr>
           <p:cNvSpPr/>
           <p:nvPr/>
         </p:nvSpPr>
@@ -11797,7 +12432,13 @@
       </p:sp>
       <p:pic>
         <p:nvPicPr>
-          <p:cNvPr id="8" name="Image 0" descr="C:\Users\whale\git\mwb-b02\presentations\_build\icons\FaLock.png">    </p:cNvPr>
+          <p:cNvPr id="8" name="Image 0" descr="">
+            <a:extLst>
+              <a:ext uri="{C183D7F6-B498-43B3-948B-1728B52AA6E4}">
+                <adec:decorative xmlns:adec="http://schemas.microsoft.com/office/drawing/2017/decorative" val="1"/>
+              </a:ext>
+            </a:extLst>
+          </p:cNvPr>
           <p:cNvPicPr>
             <a:picLocks noChangeAspect="1"/>
           </p:cNvPicPr>
@@ -11950,7 +12591,13 @@
       </p:sp>
       <p:sp>
         <p:nvSpPr>
-          <p:cNvPr id="11" name="PHS"/>
+          <p:cNvPr id="11" name="PHS" descr="">
+            <a:extLst>
+              <a:ext uri="{C183D7F6-B498-43B3-948B-1728B52AA6E4}">
+                <adec:decorative xmlns:adec="http://schemas.microsoft.com/office/drawing/2017/decorative" val="1"/>
+              </a:ext>
+            </a:extLst>
+          </p:cNvPr>
           <p:cNvSpPr/>
           <p:nvPr/>
         </p:nvSpPr>
@@ -11984,7 +12631,13 @@
       </p:sp>
       <p:sp>
         <p:nvSpPr>
-          <p:cNvPr id="12" name="Icon FaKey"/>
+          <p:cNvPr id="12" name="Icon FaKey" descr="">
+            <a:extLst>
+              <a:ext uri="{C183D7F6-B498-43B3-948B-1728B52AA6E4}">
+                <adec:decorative xmlns:adec="http://schemas.microsoft.com/office/drawing/2017/decorative" val="1"/>
+              </a:ext>
+            </a:extLst>
+          </p:cNvPr>
           <p:cNvSpPr/>
           <p:nvPr/>
         </p:nvSpPr>
@@ -12009,7 +12662,13 @@
       </p:sp>
       <p:pic>
         <p:nvPicPr>
-          <p:cNvPr id="13" name="Image 1" descr="C:\Users\whale\git\mwb-b02\presentations\_build\icons\FaKey.png">    </p:cNvPr>
+          <p:cNvPr id="13" name="Image 1" descr="">
+            <a:extLst>
+              <a:ext uri="{C183D7F6-B498-43B3-948B-1728B52AA6E4}">
+                <adec:decorative xmlns:adec="http://schemas.microsoft.com/office/drawing/2017/decorative" val="1"/>
+              </a:ext>
+            </a:extLst>
+          </p:cNvPr>
           <p:cNvPicPr>
             <a:picLocks noChangeAspect="1"/>
           </p:cNvPicPr>
@@ -12227,7 +12886,13 @@
       </p:sp>
       <p:sp>
         <p:nvSpPr>
-          <p:cNvPr id="3" name="Tag Who"/>
+          <p:cNvPr id="3" name="Tag Who" descr="">
+            <a:extLst>
+              <a:ext uri="{C183D7F6-B498-43B3-948B-1728B52AA6E4}">
+                <adec:decorative xmlns:adec="http://schemas.microsoft.com/office/drawing/2017/decorative" val="1"/>
+              </a:ext>
+            </a:extLst>
+          </p:cNvPr>
           <p:cNvSpPr/>
           <p:nvPr/>
         </p:nvSpPr>
@@ -12290,7 +12955,13 @@
       </p:sp>
       <p:sp>
         <p:nvSpPr>
-          <p:cNvPr id="5" name="Who col 1"/>
+          <p:cNvPr id="5" name="Who col 1" descr="">
+            <a:extLst>
+              <a:ext uri="{C183D7F6-B498-43B3-948B-1728B52AA6E4}">
+                <adec:decorative xmlns:adec="http://schemas.microsoft.com/office/drawing/2017/decorative" val="1"/>
+              </a:ext>
+            </a:extLst>
+          </p:cNvPr>
           <p:cNvSpPr/>
           <p:nvPr/>
         </p:nvSpPr>
@@ -12324,7 +12995,13 @@
       </p:sp>
       <p:sp>
         <p:nvSpPr>
-          <p:cNvPr id="6" name="Icon FaBuildingColumns"/>
+          <p:cNvPr id="6" name="Icon FaBuildingColumns" descr="">
+            <a:extLst>
+              <a:ext uri="{C183D7F6-B498-43B3-948B-1728B52AA6E4}">
+                <adec:decorative xmlns:adec="http://schemas.microsoft.com/office/drawing/2017/decorative" val="1"/>
+              </a:ext>
+            </a:extLst>
+          </p:cNvPr>
           <p:cNvSpPr/>
           <p:nvPr/>
         </p:nvSpPr>
@@ -12349,7 +13026,13 @@
       </p:sp>
       <p:pic>
         <p:nvPicPr>
-          <p:cNvPr id="7" name="Image 0" descr="C:\Users\whale\git\mwb-b02\presentations\_build\icons\FaBuildingColumns.png">    </p:cNvPr>
+          <p:cNvPr id="7" name="Image 0" descr="">
+            <a:extLst>
+              <a:ext uri="{C183D7F6-B498-43B3-948B-1728B52AA6E4}">
+                <adec:decorative xmlns:adec="http://schemas.microsoft.com/office/drawing/2017/decorative" val="1"/>
+              </a:ext>
+            </a:extLst>
+          </p:cNvPr>
           <p:cNvPicPr>
             <a:picLocks noChangeAspect="1"/>
           </p:cNvPicPr>
@@ -12536,7 +13219,13 @@
       </p:sp>
       <p:sp>
         <p:nvSpPr>
-          <p:cNvPr id="10" name="Who col 2"/>
+          <p:cNvPr id="10" name="Who col 2" descr="">
+            <a:extLst>
+              <a:ext uri="{C183D7F6-B498-43B3-948B-1728B52AA6E4}">
+                <adec:decorative xmlns:adec="http://schemas.microsoft.com/office/drawing/2017/decorative" val="1"/>
+              </a:ext>
+            </a:extLst>
+          </p:cNvPr>
           <p:cNvSpPr/>
           <p:nvPr/>
         </p:nvSpPr>
@@ -12570,7 +13259,13 @@
       </p:sp>
       <p:sp>
         <p:nvSpPr>
-          <p:cNvPr id="11" name="Icon FaUsersGear"/>
+          <p:cNvPr id="11" name="Icon FaUsersGear" descr="">
+            <a:extLst>
+              <a:ext uri="{C183D7F6-B498-43B3-948B-1728B52AA6E4}">
+                <adec:decorative xmlns:adec="http://schemas.microsoft.com/office/drawing/2017/decorative" val="1"/>
+              </a:ext>
+            </a:extLst>
+          </p:cNvPr>
           <p:cNvSpPr/>
           <p:nvPr/>
         </p:nvSpPr>
@@ -12595,7 +13290,13 @@
       </p:sp>
       <p:pic>
         <p:nvPicPr>
-          <p:cNvPr id="12" name="Image 1" descr="C:\Users\whale\git\mwb-b02\presentations\_build\icons\FaUsersGear.png">    </p:cNvPr>
+          <p:cNvPr id="12" name="Image 1" descr="">
+            <a:extLst>
+              <a:ext uri="{C183D7F6-B498-43B3-948B-1728B52AA6E4}">
+                <adec:decorative xmlns:adec="http://schemas.microsoft.com/office/drawing/2017/decorative" val="1"/>
+              </a:ext>
+            </a:extLst>
+          </p:cNvPr>
           <p:cNvPicPr>
             <a:picLocks noChangeAspect="1"/>
           </p:cNvPicPr>
@@ -12782,7 +13483,13 @@
       </p:sp>
       <p:sp>
         <p:nvSpPr>
-          <p:cNvPr id="15" name="Who col 3"/>
+          <p:cNvPr id="15" name="Who col 3" descr="">
+            <a:extLst>
+              <a:ext uri="{C183D7F6-B498-43B3-948B-1728B52AA6E4}">
+                <adec:decorative xmlns:adec="http://schemas.microsoft.com/office/drawing/2017/decorative" val="1"/>
+              </a:ext>
+            </a:extLst>
+          </p:cNvPr>
           <p:cNvSpPr/>
           <p:nvPr/>
         </p:nvSpPr>
@@ -12816,7 +13523,13 @@
       </p:sp>
       <p:sp>
         <p:nvSpPr>
-          <p:cNvPr id="16" name="Icon FaPeopleArrows"/>
+          <p:cNvPr id="16" name="Icon FaPeopleArrows" descr="">
+            <a:extLst>
+              <a:ext uri="{C183D7F6-B498-43B3-948B-1728B52AA6E4}">
+                <adec:decorative xmlns:adec="http://schemas.microsoft.com/office/drawing/2017/decorative" val="1"/>
+              </a:ext>
+            </a:extLst>
+          </p:cNvPr>
           <p:cNvSpPr/>
           <p:nvPr/>
         </p:nvSpPr>
@@ -12841,7 +13554,13 @@
       </p:sp>
       <p:pic>
         <p:nvPicPr>
-          <p:cNvPr id="17" name="Image 2" descr="C:\Users\whale\git\mwb-b02\presentations\_build\icons\FaPeopleArrows.png">    </p:cNvPr>
+          <p:cNvPr id="17" name="Image 2" descr="">
+            <a:extLst>
+              <a:ext uri="{C183D7F6-B498-43B3-948B-1728B52AA6E4}">
+                <adec:decorative xmlns:adec="http://schemas.microsoft.com/office/drawing/2017/decorative" val="1"/>
+              </a:ext>
+            </a:extLst>
+          </p:cNvPr>
           <p:cNvPicPr>
             <a:picLocks noChangeAspect="1"/>
           </p:cNvPicPr>
@@ -13028,7 +13747,13 @@
       </p:sp>
       <p:sp>
         <p:nvSpPr>
-          <p:cNvPr id="20" name="Gap owner"/>
+          <p:cNvPr id="20" name="Gap owner" descr="">
+            <a:extLst>
+              <a:ext uri="{C183D7F6-B498-43B3-948B-1728B52AA6E4}">
+                <adec:decorative xmlns:adec="http://schemas.microsoft.com/office/drawing/2017/decorative" val="1"/>
+              </a:ext>
+            </a:extLst>
+          </p:cNvPr>
           <p:cNvSpPr/>
           <p:nvPr/>
         </p:nvSpPr>
@@ -13062,7 +13787,13 @@
       </p:sp>
       <p:sp>
         <p:nvSpPr>
-          <p:cNvPr id="21" name="Icon FaSitemap"/>
+          <p:cNvPr id="21" name="Icon FaSitemap" descr="">
+            <a:extLst>
+              <a:ext uri="{C183D7F6-B498-43B3-948B-1728B52AA6E4}">
+                <adec:decorative xmlns:adec="http://schemas.microsoft.com/office/drawing/2017/decorative" val="1"/>
+              </a:ext>
+            </a:extLst>
+          </p:cNvPr>
           <p:cNvSpPr/>
           <p:nvPr/>
         </p:nvSpPr>
@@ -13087,7 +13818,13 @@
       </p:sp>
       <p:pic>
         <p:nvPicPr>
-          <p:cNvPr id="22" name="Image 3" descr="C:\Users\whale\git\mwb-b02\presentations\_build\icons\FaSitemap.png">    </p:cNvPr>
+          <p:cNvPr id="22" name="Image 3" descr="">
+            <a:extLst>
+              <a:ext uri="{C183D7F6-B498-43B3-948B-1728B52AA6E4}">
+                <adec:decorative xmlns:adec="http://schemas.microsoft.com/office/drawing/2017/decorative" val="1"/>
+              </a:ext>
+            </a:extLst>
+          </p:cNvPr>
           <p:cNvPicPr>
             <a:picLocks noChangeAspect="1"/>
           </p:cNvPicPr>
@@ -13305,7 +14042,13 @@
       </p:sp>
       <p:sp>
         <p:nvSpPr>
-          <p:cNvPr id="3" name="Tag How"/>
+          <p:cNvPr id="3" name="Tag How" descr="">
+            <a:extLst>
+              <a:ext uri="{C183D7F6-B498-43B3-948B-1728B52AA6E4}">
+                <adec:decorative xmlns:adec="http://schemas.microsoft.com/office/drawing/2017/decorative" val="1"/>
+              </a:ext>
+            </a:extLst>
+          </p:cNvPr>
           <p:cNvSpPr/>
           <p:nvPr/>
         </p:nvSpPr>
@@ -13368,7 +14111,13 @@
       </p:sp>
       <p:sp>
         <p:nvSpPr>
-          <p:cNvPr id="5" name="Step 1"/>
+          <p:cNvPr id="5" name="Step 1" descr="">
+            <a:extLst>
+              <a:ext uri="{C183D7F6-B498-43B3-948B-1728B52AA6E4}">
+                <adec:decorative xmlns:adec="http://schemas.microsoft.com/office/drawing/2017/decorative" val="1"/>
+              </a:ext>
+            </a:extLst>
+          </p:cNvPr>
           <p:cNvSpPr/>
           <p:nvPr/>
         </p:nvSpPr>
@@ -13517,7 +14266,13 @@
       </p:sp>
       <p:sp>
         <p:nvSpPr>
-          <p:cNvPr id="8" name="Step 2"/>
+          <p:cNvPr id="8" name="Step 2" descr="">
+            <a:extLst>
+              <a:ext uri="{C183D7F6-B498-43B3-948B-1728B52AA6E4}">
+                <adec:decorative xmlns:adec="http://schemas.microsoft.com/office/drawing/2017/decorative" val="1"/>
+              </a:ext>
+            </a:extLst>
+          </p:cNvPr>
           <p:cNvSpPr/>
           <p:nvPr/>
         </p:nvSpPr>
@@ -13666,7 +14421,13 @@
       </p:sp>
       <p:sp>
         <p:nvSpPr>
-          <p:cNvPr id="11" name="Step 3"/>
+          <p:cNvPr id="11" name="Step 3" descr="">
+            <a:extLst>
+              <a:ext uri="{C183D7F6-B498-43B3-948B-1728B52AA6E4}">
+                <adec:decorative xmlns:adec="http://schemas.microsoft.com/office/drawing/2017/decorative" val="1"/>
+              </a:ext>
+            </a:extLst>
+          </p:cNvPr>
           <p:cNvSpPr/>
           <p:nvPr/>
         </p:nvSpPr>
@@ -13815,7 +14576,13 @@
       </p:sp>
       <p:sp>
         <p:nvSpPr>
-          <p:cNvPr id="14" name="Step 4"/>
+          <p:cNvPr id="14" name="Step 4" descr="">
+            <a:extLst>
+              <a:ext uri="{C183D7F6-B498-43B3-948B-1728B52AA6E4}">
+                <adec:decorative xmlns:adec="http://schemas.microsoft.com/office/drawing/2017/decorative" val="1"/>
+              </a:ext>
+            </a:extLst>
+          </p:cNvPr>
           <p:cNvSpPr/>
           <p:nvPr/>
         </p:nvSpPr>
@@ -13964,7 +14731,13 @@
       </p:sp>
       <p:sp>
         <p:nvSpPr>
-          <p:cNvPr id="17" name="Step 5"/>
+          <p:cNvPr id="17" name="Step 5" descr="">
+            <a:extLst>
+              <a:ext uri="{C183D7F6-B498-43B3-948B-1728B52AA6E4}">
+                <adec:decorative xmlns:adec="http://schemas.microsoft.com/office/drawing/2017/decorative" val="1"/>
+              </a:ext>
+            </a:extLst>
+          </p:cNvPr>
           <p:cNvSpPr/>
           <p:nvPr/>
         </p:nvSpPr>
@@ -14113,7 +14886,13 @@
       </p:sp>
       <p:sp>
         <p:nvSpPr>
-          <p:cNvPr id="20" name="Rules"/>
+          <p:cNvPr id="20" name="Rules" descr="">
+            <a:extLst>
+              <a:ext uri="{C183D7F6-B498-43B3-948B-1728B52AA6E4}">
+                <adec:decorative xmlns:adec="http://schemas.microsoft.com/office/drawing/2017/decorative" val="1"/>
+              </a:ext>
+            </a:extLst>
+          </p:cNvPr>
           <p:cNvSpPr/>
           <p:nvPr/>
         </p:nvSpPr>
@@ -14147,7 +14926,13 @@
       </p:sp>
       <p:sp>
         <p:nvSpPr>
-          <p:cNvPr id="21" name="Icon FaClipboardCheck"/>
+          <p:cNvPr id="21" name="Icon FaClipboardCheck" descr="">
+            <a:extLst>
+              <a:ext uri="{C183D7F6-B498-43B3-948B-1728B52AA6E4}">
+                <adec:decorative xmlns:adec="http://schemas.microsoft.com/office/drawing/2017/decorative" val="1"/>
+              </a:ext>
+            </a:extLst>
+          </p:cNvPr>
           <p:cNvSpPr/>
           <p:nvPr/>
         </p:nvSpPr>
@@ -14172,7 +14957,13 @@
       </p:sp>
       <p:pic>
         <p:nvPicPr>
-          <p:cNvPr id="22" name="Image 0" descr="C:\Users\whale\git\mwb-b02\presentations\_build\icons\FaClipboardCheck.png">    </p:cNvPr>
+          <p:cNvPr id="22" name="Image 0" descr="">
+            <a:extLst>
+              <a:ext uri="{C183D7F6-B498-43B3-948B-1728B52AA6E4}">
+                <adec:decorative xmlns:adec="http://schemas.microsoft.com/office/drawing/2017/decorative" val="1"/>
+              </a:ext>
+            </a:extLst>
+          </p:cNvPr>
           <p:cNvPicPr>
             <a:picLocks noChangeAspect="1"/>
           </p:cNvPicPr>
@@ -14331,9 +15122,9 @@
 </file>
 
 <file path=ppt/theme/theme1.xml><?xml version="1.0" encoding="utf-8"?>
-<a:theme xmlns:a="http://schemas.openxmlformats.org/drawingml/2006/main" name="Modernization Workbook">
+<a:theme xmlns:a="http://schemas.openxmlformats.org/drawingml/2006/main" name="Federal Modernization Workbook">
   <a:themeElements>
-    <a:clrScheme name="Modernization Workbook">
+    <a:clrScheme name="Federal Modernization Workbook">
       <a:dk1>
         <a:srgbClr val="1F2A44"/>
       </a:dk1>
@@ -14371,7 +15162,7 @@
         <a:srgbClr val="334155"/>
       </a:folHlink>
     </a:clrScheme>
-    <a:fontScheme name="Modernization Workbook">
+    <a:fontScheme name="Federal Modernization Workbook">
       <a:majorFont>
         <a:latin typeface="Cambria"/>
         <a:ea typeface=""/>

</xml_diff>